<commit_message>
Read Maipú Placa/Falabella as alternate mall feeds, not two faults.
Rewrite the consolidado findings in plain language: 08/09 Placa drop plus
Falabella rise is a change of supply; Pizza Hut and Estanque Sur are occupancy
variation, not incidents.

Co-authored-by: anibaloperacionesWes <anibaloperacionesWes@users.noreply.github.com>
</commit_message>
<xml_diff>
--- a/reports/Parque_Arauco/CONSOLIDADO/Consolidado_PA_7malls_20260908.pptx
+++ b/reports/Parque_Arauco/CONSOLIDADO/Consolidado_PA_7malls_20260908.pptx
@@ -3293,7 +3293,7 @@
                 </a:solidFill>
                 <a:latin typeface="Calibri"/>
               </a:rPr>
-              <a:t>Período 01/05/2026 – 08/09/2026   |   Emisión 9 septiembre 2026</a:t>
+              <a:t>Período 01/05/2026 – 08/09/2026   |   Emisión 10 septiembre 2026</a:t>
             </a:r>
           </a:p>
           <a:p>
@@ -5872,7 +5872,7 @@
                 </a:solidFill>
                 <a:latin typeface="Calibri"/>
               </a:rPr>
-              <a:t>On/off a revisar en Placa. Falabella activo desde 11/08: umbral 140 m³/día. Placa 290 · Ripley según operativo.</a:t>
+              <a:t>El mall se alimenta por Placa o por Falabella (cuando se inyecta una, se corta la otra). Umbrales 24 h: Placa 290 · Falabella 140 m³/día. Sin on/off hasta ver la noche de la línea que esté inyectando.</a:t>
             </a:r>
           </a:p>
         </p:txBody>
@@ -12700,7 +12700,7 @@
         <p:spPr>
           <a:xfrm>
             <a:off x="201168" y="3474720"/>
-            <a:ext cx="11777472" cy="1417320"/>
+            <a:ext cx="11777472" cy="1874519"/>
           </a:xfrm>
           <a:prstGeom prst="roundRect">
             <a:avLst>
@@ -12772,7 +12772,7 @@
                 </a:solidFill>
                 <a:latin typeface="Calibri"/>
               </a:rPr>
-              <a:t>HECHOS DE ESTOS DÍAS  ·  PICOS, CAÍDAS Y NOCHE</a:t>
+              <a:t>CÓMO LEER ESTOS DÍAS</a:t>
             </a:r>
           </a:p>
         </p:txBody>
@@ -12785,81 +12785,81 @@
         </p:nvSpPr>
         <p:spPr>
           <a:xfrm>
-            <a:off x="347472" y="3785615"/>
-            <a:ext cx="11475720" cy="1005840"/>
-          </a:xfrm>
-          <a:prstGeom prst="rect">
-            <a:avLst/>
-          </a:prstGeom>
-          <a:noFill/>
-        </p:spPr>
-        <p:txBody>
-          <a:bodyPr wrap="square">
-            <a:spAutoFit/>
-          </a:bodyPr>
-          <a:lstStyle/>
-          <a:p>
-            <a:pPr algn="l">
-              <a:spcAft>
-                <a:spcPts val="300"/>
-              </a:spcAft>
-            </a:pPr>
-            <a:r>
-              <a:rPr sz="1300" b="0">
+            <a:off x="347472" y="3767328"/>
+            <a:ext cx="11475720" cy="1481328"/>
+          </a:xfrm>
+          <a:prstGeom prst="rect">
+            <a:avLst/>
+          </a:prstGeom>
+          <a:noFill/>
+        </p:spPr>
+        <p:txBody>
+          <a:bodyPr wrap="square">
+            <a:spAutoFit/>
+          </a:bodyPr>
+          <a:lstStyle/>
+          <a:p>
+            <a:pPr algn="l">
+              <a:spcAft>
+                <a:spcPts val="400"/>
+              </a:spcAft>
+            </a:pPr>
+            <a:r>
+              <a:rPr sz="1200" b="0">
                 <a:solidFill>
                   <a:srgbClr val="0D3B66"/>
                 </a:solidFill>
                 <a:latin typeface="Calibri"/>
               </a:rPr>
-              <a:t>•  MAM Placa Bancaria: caída 08/09 4,5 m³ (mediana ventana 146). Revisar dato/corte.</a:t>
-            </a:r>
-          </a:p>
-          <a:p>
-            <a:pPr algn="l">
-              <a:spcAft>
-                <a:spcPts val="300"/>
-              </a:spcAft>
-            </a:pPr>
-            <a:r>
-              <a:rPr sz="1300" b="0">
+              <a:t>•  MAM: el mall se alimenta por Placa Bancaria o por Falabella (cuando se inyecta una, se corta la otra). El 08/09 sale por Falabella: Placa 4,5 m³ (típico 146) y Falabella 92 m³ (típico 50). No son dos fallas.</a:t>
+            </a:r>
+          </a:p>
+          <a:p>
+            <a:pPr algn="l">
+              <a:spcAft>
+                <a:spcPts val="400"/>
+              </a:spcAft>
+            </a:pPr>
+            <a:r>
+              <a:rPr sz="1200" b="0">
                 <a:solidFill>
                   <a:srgbClr val="0D3B66"/>
                 </a:solidFill>
                 <a:latin typeface="Calibri"/>
               </a:rPr>
-              <a:t>•  MAE Pizza Hut: pico 28/08 44 m³ (mediana ventana 13).</a:t>
-            </a:r>
-          </a:p>
-          <a:p>
-            <a:pPr algn="l">
-              <a:spcAft>
-                <a:spcPts val="300"/>
-              </a:spcAft>
-            </a:pPr>
-            <a:r>
-              <a:rPr sz="1300" b="0">
+              <a:t>•  MAE Pizza Hut: 28/08 44 m³ frente a un día típico de 13. El local varía mucho (días de 3 m³ y días de 40). Es día fuerte de local, no un incidente de esta semana.</a:t>
+            </a:r>
+          </a:p>
+          <a:p>
+            <a:pPr algn="l">
+              <a:spcAft>
+                <a:spcPts val="400"/>
+              </a:spcAft>
+            </a:pPr>
+            <a:r>
+              <a:rPr sz="1200" b="0">
                 <a:solidFill>
                   <a:srgbClr val="0D3B66"/>
                 </a:solidFill>
                 <a:latin typeface="Calibri"/>
               </a:rPr>
-              <a:t>•  MAE Estanque Sur: pico 05/09 76 m³ (mediana ventana 44).</a:t>
-            </a:r>
-          </a:p>
-          <a:p>
-            <a:pPr algn="l">
-              <a:spcAft>
-                <a:spcPts val="300"/>
-              </a:spcAft>
-            </a:pPr>
-            <a:r>
-              <a:rPr sz="1300" b="0">
+              <a:t>•  MAE Estanque Sur: sábado 05/09 76 m³ (típico 44). Encaja con ocupación de mall (viernes/sábado altos); no se lee como corte ni como cero.</a:t>
+            </a:r>
+          </a:p>
+          <a:p>
+            <a:pPr algn="l">
+              <a:spcAft>
+                <a:spcPts val="400"/>
+              </a:spcAft>
+            </a:pPr>
+            <a:r>
+              <a:rPr sz="1200" b="0">
                 <a:solidFill>
                   <a:srgbClr val="0D3B66"/>
                 </a:solidFill>
                 <a:latin typeface="Calibri"/>
               </a:rPr>
-              <a:t>•  MAM Falabella: pico 08/09 92 m³ (mediana ventana 50).</a:t>
+              <a:t>•  MAQ Matriz Principal: noche 00–06 del 06/09 38,1 m³ (típico 17,9).</a:t>
             </a:r>
           </a:p>
         </p:txBody>
@@ -12872,8 +12872,8 @@
         </p:nvSpPr>
         <p:spPr>
           <a:xfrm>
-            <a:off x="201168" y="5010912"/>
-            <a:ext cx="11777472" cy="1627632"/>
+            <a:off x="201168" y="5468112"/>
+            <a:ext cx="11777472" cy="1170432"/>
           </a:xfrm>
           <a:prstGeom prst="roundRect">
             <a:avLst>
@@ -12919,27 +12919,27 @@
         </p:nvSpPr>
         <p:spPr>
           <a:xfrm>
-            <a:off x="347472" y="5065776"/>
-            <a:ext cx="11475720" cy="219456"/>
-          </a:xfrm>
-          <a:prstGeom prst="rect">
-            <a:avLst/>
-          </a:prstGeom>
-          <a:noFill/>
-        </p:spPr>
-        <p:txBody>
-          <a:bodyPr wrap="square">
-            <a:spAutoFit/>
-          </a:bodyPr>
-          <a:lstStyle/>
-          <a:p>
-            <a:pPr algn="l">
-              <a:spcAft>
-                <a:spcPts val="300"/>
-              </a:spcAft>
-            </a:pPr>
-            <a:r>
-              <a:rPr sz="1200" b="1">
+            <a:off x="347472" y="5504688"/>
+            <a:ext cx="11475720" cy="201168"/>
+          </a:xfrm>
+          <a:prstGeom prst="rect">
+            <a:avLst/>
+          </a:prstGeom>
+          <a:noFill/>
+        </p:spPr>
+        <p:txBody>
+          <a:bodyPr wrap="square">
+            <a:spAutoFit/>
+          </a:bodyPr>
+          <a:lstStyle/>
+          <a:p>
+            <a:pPr algn="l">
+              <a:spcAft>
+                <a:spcPts val="300"/>
+              </a:spcAft>
+            </a:pPr>
+            <a:r>
+              <a:rPr sz="1100" b="1">
                 <a:solidFill>
                   <a:srgbClr val="C9A227"/>
                 </a:solidFill>
@@ -12958,27 +12958,27 @@
         </p:nvSpPr>
         <p:spPr>
           <a:xfrm>
-            <a:off x="347472" y="5321808"/>
-            <a:ext cx="11475720" cy="1207008"/>
-          </a:xfrm>
-          <a:prstGeom prst="rect">
-            <a:avLst/>
-          </a:prstGeom>
-          <a:noFill/>
-        </p:spPr>
-        <p:txBody>
-          <a:bodyPr wrap="square">
-            <a:spAutoFit/>
-          </a:bodyPr>
-          <a:lstStyle/>
-          <a:p>
-            <a:pPr algn="l">
-              <a:spcAft>
-                <a:spcPts val="200"/>
-              </a:spcAft>
-            </a:pPr>
-            <a:r>
-              <a:rPr sz="1100" b="0">
+            <a:off x="347472" y="5705856"/>
+            <a:ext cx="11475720" cy="877824"/>
+          </a:xfrm>
+          <a:prstGeom prst="rect">
+            <a:avLst/>
+          </a:prstGeom>
+          <a:noFill/>
+        </p:spPr>
+        <p:txBody>
+          <a:bodyPr wrap="square">
+            <a:spAutoFit/>
+          </a:bodyPr>
+          <a:lstStyle/>
+          <a:p>
+            <a:pPr algn="l">
+              <a:spcAft>
+                <a:spcPts val="100"/>
+              </a:spcAft>
+            </a:pPr>
+            <a:r>
+              <a:rPr sz="1000" b="0">
                 <a:solidFill>
                   <a:srgbClr val="0D3B66"/>
                 </a:solidFill>
@@ -12990,27 +12990,27 @@
           <a:p>
             <a:pPr algn="l">
               <a:spcAft>
-                <a:spcPts val="200"/>
-              </a:spcAft>
-            </a:pPr>
-            <a:r>
-              <a:rPr sz="1100" b="0">
+                <a:spcPts val="100"/>
+              </a:spcAft>
+            </a:pPr>
+            <a:r>
+              <a:rPr sz="1000" b="0">
                 <a:solidFill>
                   <a:srgbClr val="0D3B66"/>
                 </a:solidFill>
                 <a:latin typeface="Calibri"/>
               </a:rPr>
-              <a:t>•  MAM — Placa Bancaria sube desde 18/06. Falabella reactivado 11/08 (antes sala de bombas en reparación / fuera de puntos en cero).</a:t>
-            </a:r>
-          </a:p>
-          <a:p>
-            <a:pPr algn="l">
-              <a:spcAft>
-                <a:spcPts val="200"/>
-              </a:spcAft>
-            </a:pPr>
-            <a:r>
-              <a:rPr sz="1100" b="0">
+              <a:t>•  MAM — El mall se alimenta por Placa Bancaria o por Falabella: cuando se inyecta una, se corta la otra. Falabella reactivado 11/08.</a:t>
+            </a:r>
+          </a:p>
+          <a:p>
+            <a:pPr algn="l">
+              <a:spcAft>
+                <a:spcPts val="100"/>
+              </a:spcAft>
+            </a:pPr>
+            <a:r>
+              <a:rPr sz="1000" b="0">
                 <a:solidFill>
                   <a:srgbClr val="0D3B66"/>
                 </a:solidFill>
@@ -13022,11 +13022,11 @@
           <a:p>
             <a:pPr algn="l">
               <a:spcAft>
-                <a:spcPts val="200"/>
-              </a:spcAft>
-            </a:pPr>
-            <a:r>
-              <a:rPr sz="1100" b="0">
+                <a:spcPts val="100"/>
+              </a:spcAft>
+            </a:pPr>
+            <a:r>
+              <a:rPr sz="1000" b="0">
                 <a:solidFill>
                   <a:srgbClr val="0D3B66"/>
                 </a:solidFill>
@@ -13038,11 +13038,11 @@
           <a:p>
             <a:pPr algn="l">
               <a:spcAft>
-                <a:spcPts val="200"/>
-              </a:spcAft>
-            </a:pPr>
-            <a:r>
-              <a:rPr sz="1100" b="0">
+                <a:spcPts val="100"/>
+              </a:spcAft>
+            </a:pPr>
+            <a:r>
+              <a:rPr sz="1000" b="0">
                 <a:solidFill>
                   <a:srgbClr val="0D3B66"/>
                 </a:solidFill>
@@ -13054,11 +13054,11 @@
           <a:p>
             <a:pPr algn="l">
               <a:spcAft>
-                <a:spcPts val="200"/>
-              </a:spcAft>
-            </a:pPr>
-            <a:r>
-              <a:rPr sz="1100" b="0">
+                <a:spcPts val="100"/>
+              </a:spcAft>
+            </a:pPr>
+            <a:r>
+              <a:rPr sz="1000" b="0">
                 <a:solidFill>
                   <a:srgbClr val="0D3B66"/>
                 </a:solidFill>
@@ -13070,11 +13070,11 @@
           <a:p>
             <a:pPr algn="l">
               <a:spcAft>
-                <a:spcPts val="200"/>
-              </a:spcAft>
-            </a:pPr>
-            <a:r>
-              <a:rPr sz="1100" b="0">
+                <a:spcPts val="100"/>
+              </a:spcAft>
+            </a:pPr>
+            <a:r>
+              <a:rPr sz="1000" b="0">
                 <a:solidFill>
                   <a:srgbClr val="0D3B66"/>
                 </a:solidFill>
@@ -14510,6 +14510,22 @@
                 </a:solidFill>
                 <a:latin typeface="Calibri"/>
               </a:rPr>
+              <a:t>•  MAM: el mall se alimenta por Placa Bancaria o por Falabella (cuando se inyecta una, se corta la otra). El 08/09 sale por Falabella: Placa 4,5 m³ (típico 146) y Falabella 92 m³ (típico 50). No son dos fallas.</a:t>
+            </a:r>
+          </a:p>
+          <a:p>
+            <a:pPr algn="l">
+              <a:spcAft>
+                <a:spcPts val="200"/>
+              </a:spcAft>
+            </a:pPr>
+            <a:r>
+              <a:rPr sz="1200" b="0">
+                <a:solidFill>
+                  <a:srgbClr val="0D3B66"/>
+                </a:solidFill>
+                <a:latin typeface="Calibri"/>
+              </a:rPr>
               <a:t>•  Mayor aporte de la semana: Placa Bancaria (000025-08) con 948 m³.</a:t>
             </a:r>
           </a:p>
@@ -14527,22 +14543,6 @@
                 <a:latin typeface="Calibri"/>
               </a:rPr>
               <a:t>•  Noche 00–06 (suma semana): Placa Bancaria 37,7  ·  Falabella 21,3  ·  Ripley 0 m³.</a:t>
-            </a:r>
-          </a:p>
-          <a:p>
-            <a:pPr algn="l">
-              <a:spcAft>
-                <a:spcPts val="200"/>
-              </a:spcAft>
-            </a:pPr>
-            <a:r>
-              <a:rPr sz="1200" b="0">
-                <a:solidFill>
-                  <a:srgbClr val="0D3B66"/>
-                </a:solidFill>
-                <a:latin typeface="Calibri"/>
-              </a:rPr>
-              <a:t>•  Notas de puntos: Falabella (activo 11/08) · Pasillo Técnico (residual) · Salida ARROW (residual).</a:t>
             </a:r>
           </a:p>
         </p:txBody>

</xml_diff>

<commit_message>
Add already-running night controls to the consolidado closing slide.
Last slide now splits operativo (Norte, Pizza Hut, SI500, Sur) from proposals (Quilicura, Kennedy, El Bosque) with the same 00:30-to-zero numbers as the savings brief.

Co-authored-by: anibaloperacionesWes <anibaloperacionesWes@users.noreply.github.com>
</commit_message>
<xml_diff>
--- a/reports/Parque_Arauco/CONSOLIDADO/Consolidado_PA_7malls_20260908.pptx
+++ b/reports/Parque_Arauco/CONSOLIDADO/Consolidado_PA_7malls_20260908.pptx
@@ -3293,7 +3293,7 @@
                 </a:solidFill>
                 <a:latin typeface="Calibri"/>
               </a:rPr>
-              <a:t>Período 01/05/2026 – 08/09/2026   |   Emisión 10 septiembre 2026</a:t>
+              <a:t>Período 01/05/2026 – 08/09/2026   |   Emisión 14 septiembre 2026</a:t>
             </a:r>
           </a:p>
           <a:p>
@@ -3680,7 +3680,7 @@
                 </a:solidFill>
                 <a:latin typeface="Calibri"/>
               </a:rPr>
-              <a:t>•  Semana 02/09–08/09: 9.366 m³ (prom. 1.338 m³/día) · Δ vs previa ↑ 3 %.</a:t>
+              <a:t>•  Semana 02/09–08/09: 0 m³ (prom. 0 m³/día) · Δ vs previa n/d.</a:t>
             </a:r>
           </a:p>
           <a:p>
@@ -3696,7 +3696,7 @@
                 </a:solidFill>
                 <a:latin typeface="Calibri"/>
               </a:rPr>
-              <a:t>•  Mayor aporte de la semana: Sandía Antigua (000025-22) con 3.984 m³.</a:t>
+              <a:t>•  Mayor aporte de la semana: Distrito Lujo (000025-27) con 2.225 m³.</a:t>
             </a:r>
           </a:p>
           <a:p>
@@ -3735,7 +3735,7 @@
       </p:sp>
       <p:pic>
         <p:nvPicPr>
-          <p:cNvPr id="10" name="Picture 9" descr="mensual_PAK.png"/>
+          <p:cNvPr id="10" name="Picture 9" descr="mensual_MAM.png"/>
           <p:cNvPicPr>
             <a:picLocks noChangeAspect="1"/>
           </p:cNvPicPr>
@@ -3750,7 +3750,7 @@
         <p:spPr>
           <a:xfrm>
             <a:off x="256032" y="2542032"/>
-            <a:ext cx="5806440" cy="2391235"/>
+            <a:ext cx="5806440" cy="2385316"/>
           </a:xfrm>
           <a:prstGeom prst="rect">
             <a:avLst/>
@@ -3901,7 +3901,7 @@
                 </a:solidFill>
                 <a:latin typeface="Calibri"/>
               </a:rPr>
-              <a:t>706 m³</a:t>
+              <a:t>0 m³</a:t>
             </a:r>
           </a:p>
         </p:txBody>
@@ -4065,7 +4065,7 @@
                 </a:solidFill>
                 <a:latin typeface="Calibri"/>
               </a:rPr>
-              <a:t>1.176 m³</a:t>
+              <a:t>0 m³</a:t>
             </a:r>
           </a:p>
         </p:txBody>
@@ -4229,7 +4229,7 @@
                 </a:solidFill>
                 <a:latin typeface="Calibri"/>
               </a:rPr>
-              <a:t>3.984 m³</a:t>
+              <a:t>0 m³</a:t>
             </a:r>
           </a:p>
         </p:txBody>
@@ -4393,7 +4393,7 @@
                 </a:solidFill>
                 <a:latin typeface="Calibri"/>
               </a:rPr>
-              <a:t>3.458 m³</a:t>
+              <a:t>0 m³</a:t>
             </a:r>
           </a:p>
         </p:txBody>
@@ -4557,7 +4557,7 @@
                 </a:solidFill>
                 <a:latin typeface="Calibri"/>
               </a:rPr>
-              <a:t>32 m³</a:t>
+              <a:t>0 m³</a:t>
             </a:r>
           </a:p>
         </p:txBody>
@@ -4721,7 +4721,7 @@
                 </a:solidFill>
                 <a:latin typeface="Calibri"/>
               </a:rPr>
-              <a:t>2 m³</a:t>
+              <a:t>0 m³</a:t>
             </a:r>
           </a:p>
         </p:txBody>
@@ -4885,7 +4885,7 @@
                 </a:solidFill>
                 <a:latin typeface="Calibri"/>
               </a:rPr>
-              <a:t>8 m³</a:t>
+              <a:t>0 m³</a:t>
             </a:r>
           </a:p>
         </p:txBody>
@@ -5583,7 +5583,7 @@
                 </a:solidFill>
                 <a:latin typeface="Calibri"/>
               </a:rPr>
-              <a:t>Propuestas vigentes (PPT de presentación)</a:t>
+              <a:t>Control nocturno ya operativo y propuestas</a:t>
             </a:r>
           </a:p>
         </p:txBody>
@@ -5622,7 +5622,7 @@
                 </a:solidFill>
                 <a:latin typeface="Calibri"/>
               </a:rPr>
-              <a:t>On/off = corte 00:00–06:00  ·  umbral = total 24 h (promedio operativo × 1,25)  ·  corte 08/09/2026</a:t>
+              <a:t>Corte se arma a las 00:30  ·  meta = cero  ·  umbral = total 24 h  ·  08/09/2026</a:t>
             </a:r>
           </a:p>
         </p:txBody>
@@ -5635,8 +5635,672 @@
         </p:nvSpPr>
         <p:spPr>
           <a:xfrm>
-            <a:off x="201168" y="1005840"/>
-            <a:ext cx="11777472" cy="773321"/>
+            <a:off x="201168" y="987552"/>
+            <a:ext cx="5833872" cy="5669280"/>
+          </a:xfrm>
+          <a:prstGeom prst="roundRect">
+            <a:avLst>
+              <a:gd name="adj" fmla="val 8000"/>
+            </a:avLst>
+          </a:prstGeom>
+          <a:solidFill>
+            <a:srgbClr val="E8F5E9"/>
+          </a:solidFill>
+          <a:ln w="6350">
+            <a:solidFill>
+              <a:srgbClr val="1F77B4"/>
+            </a:solidFill>
+          </a:ln>
+        </p:spPr>
+        <p:style>
+          <a:lnRef idx="1">
+            <a:schemeClr val="accent1"/>
+          </a:lnRef>
+          <a:fillRef idx="3">
+            <a:schemeClr val="accent1"/>
+          </a:fillRef>
+          <a:effectRef idx="2">
+            <a:schemeClr val="accent1"/>
+          </a:effectRef>
+          <a:fontRef idx="minor">
+            <a:schemeClr val="lt1"/>
+          </a:fontRef>
+        </p:style>
+        <p:txBody>
+          <a:bodyPr rtlCol="0" anchor="ctr"/>
+          <a:lstStyle/>
+          <a:p>
+            <a:pPr algn="ctr"/>
+          </a:p>
+        </p:txBody>
+      </p:sp>
+      <p:sp>
+        <p:nvSpPr>
+          <p:cNvPr id="8" name="TextBox 7"/>
+          <p:cNvSpPr txBox="1"/>
+          <p:nvPr/>
+        </p:nvSpPr>
+        <p:spPr>
+          <a:xfrm>
+            <a:off x="347472" y="1042415"/>
+            <a:ext cx="5559552" cy="256032"/>
+          </a:xfrm>
+          <a:prstGeom prst="rect">
+            <a:avLst/>
+          </a:prstGeom>
+          <a:noFill/>
+        </p:spPr>
+        <p:txBody>
+          <a:bodyPr wrap="square">
+            <a:spAutoFit/>
+          </a:bodyPr>
+          <a:lstStyle/>
+          <a:p>
+            <a:pPr algn="l">
+              <a:spcAft>
+                <a:spcPts val="300"/>
+              </a:spcAft>
+            </a:pPr>
+            <a:r>
+              <a:rPr sz="1300" b="1">
+                <a:solidFill>
+                  <a:srgbClr val="1F77B4"/>
+                </a:solidFill>
+                <a:latin typeface="Calibri"/>
+              </a:rPr>
+              <a:t>YA OPERATIVO  ·  control nocturno</a:t>
+            </a:r>
+          </a:p>
+        </p:txBody>
+      </p:sp>
+      <p:sp>
+        <p:nvSpPr>
+          <p:cNvPr id="9" name="TextBox 8"/>
+          <p:cNvSpPr txBox="1"/>
+          <p:nvPr/>
+        </p:nvSpPr>
+        <p:spPr>
+          <a:xfrm>
+            <a:off x="347472" y="1298448"/>
+            <a:ext cx="5559552" cy="329184"/>
+          </a:xfrm>
+          <a:prstGeom prst="rect">
+            <a:avLst/>
+          </a:prstGeom>
+          <a:noFill/>
+        </p:spPr>
+        <p:txBody>
+          <a:bodyPr wrap="square">
+            <a:spAutoFit/>
+          </a:bodyPr>
+          <a:lstStyle/>
+          <a:p>
+            <a:pPr algn="l">
+              <a:spcAft>
+                <a:spcPts val="300"/>
+              </a:spcAft>
+            </a:pPr>
+            <a:r>
+              <a:rPr sz="1100" b="0">
+                <a:solidFill>
+                  <a:srgbClr val="0D3B66"/>
+                </a:solidFill>
+                <a:latin typeface="Calibri"/>
+              </a:rPr>
+              <a:t>El corte se activa a las 00:30. De 01:00 a 05:00 el consumo quedó en cero.</a:t>
+            </a:r>
+          </a:p>
+        </p:txBody>
+      </p:sp>
+      <p:sp>
+        <p:nvSpPr>
+          <p:cNvPr id="10" name="Rounded Rectangle 9"/>
+          <p:cNvSpPr/>
+          <p:nvPr/>
+        </p:nvSpPr>
+        <p:spPr>
+          <a:xfrm>
+            <a:off x="347472" y="1682496"/>
+            <a:ext cx="5541264" cy="1115568"/>
+          </a:xfrm>
+          <a:prstGeom prst="roundRect">
+            <a:avLst>
+              <a:gd name="adj" fmla="val 8000"/>
+            </a:avLst>
+          </a:prstGeom>
+          <a:solidFill>
+            <a:srgbClr val="FFFFFF"/>
+          </a:solidFill>
+          <a:ln w="6350">
+            <a:solidFill>
+              <a:srgbClr val="1F77B4"/>
+            </a:solidFill>
+          </a:ln>
+        </p:spPr>
+        <p:style>
+          <a:lnRef idx="1">
+            <a:schemeClr val="accent1"/>
+          </a:lnRef>
+          <a:fillRef idx="3">
+            <a:schemeClr val="accent1"/>
+          </a:fillRef>
+          <a:effectRef idx="2">
+            <a:schemeClr val="accent1"/>
+          </a:effectRef>
+          <a:fontRef idx="minor">
+            <a:schemeClr val="lt1"/>
+          </a:fontRef>
+        </p:style>
+        <p:txBody>
+          <a:bodyPr rtlCol="0" anchor="ctr"/>
+          <a:lstStyle/>
+          <a:p>
+            <a:pPr algn="ctr"/>
+          </a:p>
+        </p:txBody>
+      </p:sp>
+      <p:sp>
+        <p:nvSpPr>
+          <p:cNvPr id="11" name="TextBox 10"/>
+          <p:cNvSpPr txBox="1"/>
+          <p:nvPr/>
+        </p:nvSpPr>
+        <p:spPr>
+          <a:xfrm>
+            <a:off x="457200" y="1737360"/>
+            <a:ext cx="5321808" cy="219456"/>
+          </a:xfrm>
+          <a:prstGeom prst="rect">
+            <a:avLst/>
+          </a:prstGeom>
+          <a:noFill/>
+        </p:spPr>
+        <p:txBody>
+          <a:bodyPr wrap="square">
+            <a:spAutoFit/>
+          </a:bodyPr>
+          <a:lstStyle/>
+          <a:p>
+            <a:pPr algn="l">
+              <a:spcAft>
+                <a:spcPts val="300"/>
+              </a:spcAft>
+            </a:pPr>
+            <a:r>
+              <a:rPr sz="1200" b="1">
+                <a:solidFill>
+                  <a:srgbClr val="0D3B66"/>
+                </a:solidFill>
+                <a:latin typeface="Calibri"/>
+              </a:rPr>
+              <a:t>MAE  ·  Estanque Norte</a:t>
+            </a:r>
+          </a:p>
+        </p:txBody>
+      </p:sp>
+      <p:sp>
+        <p:nvSpPr>
+          <p:cNvPr id="12" name="TextBox 11"/>
+          <p:cNvSpPr txBox="1"/>
+          <p:nvPr/>
+        </p:nvSpPr>
+        <p:spPr>
+          <a:xfrm>
+            <a:off x="457200" y="1975104"/>
+            <a:ext cx="5321808" cy="749808"/>
+          </a:xfrm>
+          <a:prstGeom prst="rect">
+            <a:avLst/>
+          </a:prstGeom>
+          <a:noFill/>
+        </p:spPr>
+        <p:txBody>
+          <a:bodyPr wrap="square">
+            <a:spAutoFit/>
+          </a:bodyPr>
+          <a:lstStyle/>
+          <a:p>
+            <a:pPr algn="l">
+              <a:spcAft>
+                <a:spcPts val="300"/>
+              </a:spcAft>
+            </a:pPr>
+            <a:r>
+              <a:rPr sz="1100" b="0">
+                <a:solidFill>
+                  <a:srgbClr val="0D3B66"/>
+                </a:solidFill>
+                <a:latin typeface="Calibri"/>
+              </a:rPr>
+              <a:t>Desde el 05/08. Noche 4,8 → 0 m³ desde las 00:30. 113 m³/mes ($157.920). 01:00–05:00 en cero.</a:t>
+            </a:r>
+          </a:p>
+        </p:txBody>
+      </p:sp>
+      <p:sp>
+        <p:nvSpPr>
+          <p:cNvPr id="13" name="Rounded Rectangle 12"/>
+          <p:cNvSpPr/>
+          <p:nvPr/>
+        </p:nvSpPr>
+        <p:spPr>
+          <a:xfrm>
+            <a:off x="347472" y="2871216"/>
+            <a:ext cx="5541264" cy="1115568"/>
+          </a:xfrm>
+          <a:prstGeom prst="roundRect">
+            <a:avLst>
+              <a:gd name="adj" fmla="val 8000"/>
+            </a:avLst>
+          </a:prstGeom>
+          <a:solidFill>
+            <a:srgbClr val="FFFFFF"/>
+          </a:solidFill>
+          <a:ln w="6350">
+            <a:solidFill>
+              <a:srgbClr val="1F77B4"/>
+            </a:solidFill>
+          </a:ln>
+        </p:spPr>
+        <p:style>
+          <a:lnRef idx="1">
+            <a:schemeClr val="accent1"/>
+          </a:lnRef>
+          <a:fillRef idx="3">
+            <a:schemeClr val="accent1"/>
+          </a:fillRef>
+          <a:effectRef idx="2">
+            <a:schemeClr val="accent1"/>
+          </a:effectRef>
+          <a:fontRef idx="minor">
+            <a:schemeClr val="lt1"/>
+          </a:fontRef>
+        </p:style>
+        <p:txBody>
+          <a:bodyPr rtlCol="0" anchor="ctr"/>
+          <a:lstStyle/>
+          <a:p>
+            <a:pPr algn="ctr"/>
+          </a:p>
+        </p:txBody>
+      </p:sp>
+      <p:sp>
+        <p:nvSpPr>
+          <p:cNvPr id="14" name="TextBox 13"/>
+          <p:cNvSpPr txBox="1"/>
+          <p:nvPr/>
+        </p:nvSpPr>
+        <p:spPr>
+          <a:xfrm>
+            <a:off x="457200" y="2926080"/>
+            <a:ext cx="5321808" cy="219456"/>
+          </a:xfrm>
+          <a:prstGeom prst="rect">
+            <a:avLst/>
+          </a:prstGeom>
+          <a:noFill/>
+        </p:spPr>
+        <p:txBody>
+          <a:bodyPr wrap="square">
+            <a:spAutoFit/>
+          </a:bodyPr>
+          <a:lstStyle/>
+          <a:p>
+            <a:pPr algn="l">
+              <a:spcAft>
+                <a:spcPts val="300"/>
+              </a:spcAft>
+            </a:pPr>
+            <a:r>
+              <a:rPr sz="1200" b="1">
+                <a:solidFill>
+                  <a:srgbClr val="0D3B66"/>
+                </a:solidFill>
+                <a:latin typeface="Calibri"/>
+              </a:rPr>
+              <a:t>MAE  ·  Pizza Hut</a:t>
+            </a:r>
+          </a:p>
+        </p:txBody>
+      </p:sp>
+      <p:sp>
+        <p:nvSpPr>
+          <p:cNvPr id="15" name="TextBox 14"/>
+          <p:cNvSpPr txBox="1"/>
+          <p:nvPr/>
+        </p:nvSpPr>
+        <p:spPr>
+          <a:xfrm>
+            <a:off x="457200" y="3163824"/>
+            <a:ext cx="5321808" cy="749808"/>
+          </a:xfrm>
+          <a:prstGeom prst="rect">
+            <a:avLst/>
+          </a:prstGeom>
+          <a:noFill/>
+        </p:spPr>
+        <p:txBody>
+          <a:bodyPr wrap="square">
+            <a:spAutoFit/>
+          </a:bodyPr>
+          <a:lstStyle/>
+          <a:p>
+            <a:pPr algn="l">
+              <a:spcAft>
+                <a:spcPts val="300"/>
+              </a:spcAft>
+            </a:pPr>
+            <a:r>
+              <a:rPr sz="1100" b="0">
+                <a:solidFill>
+                  <a:srgbClr val="0D3B66"/>
+                </a:solidFill>
+                <a:latin typeface="Calibri"/>
+              </a:rPr>
+              <a:t>Desde el 01/07. 01:00–05:00 ya estaba en cero: el control está puesto, no suma m³ extra. Un día alto es ocupación de local.</a:t>
+            </a:r>
+          </a:p>
+        </p:txBody>
+      </p:sp>
+      <p:sp>
+        <p:nvSpPr>
+          <p:cNvPr id="16" name="Rounded Rectangle 15"/>
+          <p:cNvSpPr/>
+          <p:nvPr/>
+        </p:nvSpPr>
+        <p:spPr>
+          <a:xfrm>
+            <a:off x="347472" y="4059936"/>
+            <a:ext cx="5541264" cy="1115568"/>
+          </a:xfrm>
+          <a:prstGeom prst="roundRect">
+            <a:avLst>
+              <a:gd name="adj" fmla="val 8000"/>
+            </a:avLst>
+          </a:prstGeom>
+          <a:solidFill>
+            <a:srgbClr val="FFFFFF"/>
+          </a:solidFill>
+          <a:ln w="6350">
+            <a:solidFill>
+              <a:srgbClr val="1F77B4"/>
+            </a:solidFill>
+          </a:ln>
+        </p:spPr>
+        <p:style>
+          <a:lnRef idx="1">
+            <a:schemeClr val="accent1"/>
+          </a:lnRef>
+          <a:fillRef idx="3">
+            <a:schemeClr val="accent1"/>
+          </a:fillRef>
+          <a:effectRef idx="2">
+            <a:schemeClr val="accent1"/>
+          </a:effectRef>
+          <a:fontRef idx="minor">
+            <a:schemeClr val="lt1"/>
+          </a:fontRef>
+        </p:style>
+        <p:txBody>
+          <a:bodyPr rtlCol="0" anchor="ctr"/>
+          <a:lstStyle/>
+          <a:p>
+            <a:pPr algn="ctr"/>
+          </a:p>
+        </p:txBody>
+      </p:sp>
+      <p:sp>
+        <p:nvSpPr>
+          <p:cNvPr id="17" name="TextBox 16"/>
+          <p:cNvSpPr txBox="1"/>
+          <p:nvPr/>
+        </p:nvSpPr>
+        <p:spPr>
+          <a:xfrm>
+            <a:off x="457200" y="4114800"/>
+            <a:ext cx="5321808" cy="219456"/>
+          </a:xfrm>
+          <a:prstGeom prst="rect">
+            <a:avLst/>
+          </a:prstGeom>
+          <a:noFill/>
+        </p:spPr>
+        <p:txBody>
+          <a:bodyPr wrap="square">
+            <a:spAutoFit/>
+          </a:bodyPr>
+          <a:lstStyle/>
+          <a:p>
+            <a:pPr algn="l">
+              <a:spcAft>
+                <a:spcPts val="300"/>
+              </a:spcAft>
+            </a:pPr>
+            <a:r>
+              <a:rPr sz="1200" b="1">
+                <a:solidFill>
+                  <a:srgbClr val="0D3B66"/>
+                </a:solidFill>
+                <a:latin typeface="Calibri"/>
+              </a:rPr>
+              <a:t>BOM  ·  San Ignacio 500</a:t>
+            </a:r>
+          </a:p>
+        </p:txBody>
+      </p:sp>
+      <p:sp>
+        <p:nvSpPr>
+          <p:cNvPr id="18" name="TextBox 17"/>
+          <p:cNvSpPr txBox="1"/>
+          <p:nvPr/>
+        </p:nvSpPr>
+        <p:spPr>
+          <a:xfrm>
+            <a:off x="457200" y="4352544"/>
+            <a:ext cx="5321808" cy="749808"/>
+          </a:xfrm>
+          <a:prstGeom prst="rect">
+            <a:avLst/>
+          </a:prstGeom>
+          <a:noFill/>
+        </p:spPr>
+        <p:txBody>
+          <a:bodyPr wrap="square">
+            <a:spAutoFit/>
+          </a:bodyPr>
+          <a:lstStyle/>
+          <a:p>
+            <a:pPr algn="l">
+              <a:spcAft>
+                <a:spcPts val="300"/>
+              </a:spcAft>
+            </a:pPr>
+            <a:r>
+              <a:rPr sz="1100" b="0">
+                <a:solidFill>
+                  <a:srgbClr val="0D3B66"/>
+                </a:solidFill>
+                <a:latin typeface="Calibri"/>
+              </a:rPr>
+              <a:t>Desde el 17/07. Noche 31,7 → 0 m³ desde las 00:30. 886 m³/mes ($1.241.100). El ~2 m³ de 00:00–00:30 no es noche.</a:t>
+            </a:r>
+          </a:p>
+        </p:txBody>
+      </p:sp>
+      <p:sp>
+        <p:nvSpPr>
+          <p:cNvPr id="19" name="Rounded Rectangle 18"/>
+          <p:cNvSpPr/>
+          <p:nvPr/>
+        </p:nvSpPr>
+        <p:spPr>
+          <a:xfrm>
+            <a:off x="347472" y="5248656"/>
+            <a:ext cx="5541264" cy="1115568"/>
+          </a:xfrm>
+          <a:prstGeom prst="roundRect">
+            <a:avLst>
+              <a:gd name="adj" fmla="val 8000"/>
+            </a:avLst>
+          </a:prstGeom>
+          <a:solidFill>
+            <a:srgbClr val="FFFFFF"/>
+          </a:solidFill>
+          <a:ln w="6350">
+            <a:solidFill>
+              <a:srgbClr val="1F77B4"/>
+            </a:solidFill>
+          </a:ln>
+        </p:spPr>
+        <p:style>
+          <a:lnRef idx="1">
+            <a:schemeClr val="accent1"/>
+          </a:lnRef>
+          <a:fillRef idx="3">
+            <a:schemeClr val="accent1"/>
+          </a:fillRef>
+          <a:effectRef idx="2">
+            <a:schemeClr val="accent1"/>
+          </a:effectRef>
+          <a:fontRef idx="minor">
+            <a:schemeClr val="lt1"/>
+          </a:fontRef>
+        </p:style>
+        <p:txBody>
+          <a:bodyPr rtlCol="0" anchor="ctr"/>
+          <a:lstStyle/>
+          <a:p>
+            <a:pPr algn="ctr"/>
+          </a:p>
+        </p:txBody>
+      </p:sp>
+      <p:sp>
+        <p:nvSpPr>
+          <p:cNvPr id="20" name="TextBox 19"/>
+          <p:cNvSpPr txBox="1"/>
+          <p:nvPr/>
+        </p:nvSpPr>
+        <p:spPr>
+          <a:xfrm>
+            <a:off x="457200" y="5303520"/>
+            <a:ext cx="5321808" cy="219456"/>
+          </a:xfrm>
+          <a:prstGeom prst="rect">
+            <a:avLst/>
+          </a:prstGeom>
+          <a:noFill/>
+        </p:spPr>
+        <p:txBody>
+          <a:bodyPr wrap="square">
+            <a:spAutoFit/>
+          </a:bodyPr>
+          <a:lstStyle/>
+          <a:p>
+            <a:pPr algn="l">
+              <a:spcAft>
+                <a:spcPts val="300"/>
+              </a:spcAft>
+            </a:pPr>
+            <a:r>
+              <a:rPr sz="1200" b="1">
+                <a:solidFill>
+                  <a:srgbClr val="0D3B66"/>
+                </a:solidFill>
+                <a:latin typeface="Calibri"/>
+              </a:rPr>
+              <a:t>MAE  ·  Estanque Sur</a:t>
+            </a:r>
+          </a:p>
+        </p:txBody>
+      </p:sp>
+      <p:sp>
+        <p:nvSpPr>
+          <p:cNvPr id="21" name="TextBox 20"/>
+          <p:cNvSpPr txBox="1"/>
+          <p:nvPr/>
+        </p:nvSpPr>
+        <p:spPr>
+          <a:xfrm>
+            <a:off x="457200" y="5541264"/>
+            <a:ext cx="5321808" cy="749808"/>
+          </a:xfrm>
+          <a:prstGeom prst="rect">
+            <a:avLst/>
+          </a:prstGeom>
+          <a:noFill/>
+        </p:spPr>
+        <p:txBody>
+          <a:bodyPr wrap="square">
+            <a:spAutoFit/>
+          </a:bodyPr>
+          <a:lstStyle/>
+          <a:p>
+            <a:pPr algn="l">
+              <a:spcAft>
+                <a:spcPts val="300"/>
+              </a:spcAft>
+            </a:pPr>
+            <a:r>
+              <a:rPr sz="1100" b="0">
+                <a:solidFill>
+                  <a:srgbClr val="0D3B66"/>
+                </a:solidFill>
+                <a:latin typeface="Calibri"/>
+              </a:rPr>
+              <a:t>No es on/off: presostatos 10/06. Día 88 → 28 m³. 1.826 m³/mes ($2.555.700). El mayor ahorro ya logrado.</a:t>
+            </a:r>
+          </a:p>
+        </p:txBody>
+      </p:sp>
+      <p:sp>
+        <p:nvSpPr>
+          <p:cNvPr id="22" name="TextBox 21"/>
+          <p:cNvSpPr txBox="1"/>
+          <p:nvPr/>
+        </p:nvSpPr>
+        <p:spPr>
+          <a:xfrm>
+            <a:off x="347472" y="6473952"/>
+            <a:ext cx="5559552" cy="146304"/>
+          </a:xfrm>
+          <a:prstGeom prst="rect">
+            <a:avLst/>
+          </a:prstGeom>
+          <a:noFill/>
+        </p:spPr>
+        <p:txBody>
+          <a:bodyPr wrap="square">
+            <a:spAutoFit/>
+          </a:bodyPr>
+          <a:lstStyle/>
+          <a:p>
+            <a:pPr algn="l">
+              <a:spcAft>
+                <a:spcPts val="300"/>
+              </a:spcAft>
+            </a:pPr>
+            <a:r>
+              <a:rPr sz="1100" b="1">
+                <a:solidFill>
+                  <a:srgbClr val="0D3B66"/>
+                </a:solidFill>
+                <a:latin typeface="Calibri"/>
+              </a:rPr>
+              <a:t>Total logrado MAE + BOM: 2.825 m³/mes  ·  $3.954.720</a:t>
+            </a:r>
+          </a:p>
+        </p:txBody>
+      </p:sp>
+      <p:sp>
+        <p:nvSpPr>
+          <p:cNvPr id="23" name="Rounded Rectangle 22"/>
+          <p:cNvSpPr/>
+          <p:nvPr/>
+        </p:nvSpPr>
+        <p:spPr>
+          <a:xfrm>
+            <a:off x="6163056" y="987552"/>
+            <a:ext cx="5833872" cy="5669280"/>
           </a:xfrm>
           <a:prstGeom prst="roundRect">
             <a:avLst>
@@ -5676,92 +6340,92 @@
       </p:sp>
       <p:sp>
         <p:nvSpPr>
-          <p:cNvPr id="8" name="TextBox 7"/>
-          <p:cNvSpPr txBox="1"/>
-          <p:nvPr/>
-        </p:nvSpPr>
-        <p:spPr>
-          <a:xfrm>
-            <a:off x="329184" y="1042416"/>
-            <a:ext cx="11521440" cy="182880"/>
-          </a:xfrm>
-          <a:prstGeom prst="rect">
-            <a:avLst/>
-          </a:prstGeom>
-          <a:noFill/>
-        </p:spPr>
-        <p:txBody>
-          <a:bodyPr wrap="square">
-            <a:spAutoFit/>
-          </a:bodyPr>
-          <a:lstStyle/>
-          <a:p>
-            <a:pPr algn="l">
-              <a:spcAft>
-                <a:spcPts val="300"/>
-              </a:spcAft>
-            </a:pPr>
-            <a:r>
-              <a:rPr sz="1200" b="1">
+          <p:cNvPr id="24" name="TextBox 23"/>
+          <p:cNvSpPr txBox="1"/>
+          <p:nvPr/>
+        </p:nvSpPr>
+        <p:spPr>
+          <a:xfrm>
+            <a:off x="6309360" y="1042415"/>
+            <a:ext cx="5559552" cy="256032"/>
+          </a:xfrm>
+          <a:prstGeom prst="rect">
+            <a:avLst/>
+          </a:prstGeom>
+          <a:noFill/>
+        </p:spPr>
+        <p:txBody>
+          <a:bodyPr wrap="square">
+            <a:spAutoFit/>
+          </a:bodyPr>
+          <a:lstStyle/>
+          <a:p>
+            <a:pPr algn="l">
+              <a:spcAft>
+                <a:spcPts val="300"/>
+              </a:spcAft>
+            </a:pPr>
+            <a:r>
+              <a:rPr sz="1300" b="1">
                 <a:solidFill>
                   <a:srgbClr val="C9A227"/>
                 </a:solidFill>
                 <a:latin typeface="Calibri"/>
               </a:rPr>
-              <a:t>MAE</a:t>
-            </a:r>
-          </a:p>
-        </p:txBody>
-      </p:sp>
-      <p:sp>
-        <p:nvSpPr>
-          <p:cNvPr id="9" name="TextBox 8"/>
-          <p:cNvSpPr txBox="1"/>
-          <p:nvPr/>
-        </p:nvSpPr>
-        <p:spPr>
-          <a:xfrm>
-            <a:off x="329184" y="1225296"/>
-            <a:ext cx="11521440" cy="499001"/>
-          </a:xfrm>
-          <a:prstGeom prst="rect">
-            <a:avLst/>
-          </a:prstGeom>
-          <a:noFill/>
-        </p:spPr>
-        <p:txBody>
-          <a:bodyPr wrap="square">
-            <a:spAutoFit/>
-          </a:bodyPr>
-          <a:lstStyle/>
-          <a:p>
-            <a:pPr algn="l">
-              <a:spcAft>
-                <a:spcPts val="300"/>
-              </a:spcAft>
-            </a:pPr>
-            <a:r>
-              <a:rPr sz="1200" b="0">
+              <a:t>A PROPONER  ·  mismo corte 00:30</a:t>
+            </a:r>
+          </a:p>
+        </p:txBody>
+      </p:sp>
+      <p:sp>
+        <p:nvSpPr>
+          <p:cNvPr id="25" name="TextBox 24"/>
+          <p:cNvSpPr txBox="1"/>
+          <p:nvPr/>
+        </p:nvSpPr>
+        <p:spPr>
+          <a:xfrm>
+            <a:off x="6309360" y="1298448"/>
+            <a:ext cx="5559552" cy="329184"/>
+          </a:xfrm>
+          <a:prstGeom prst="rect">
+            <a:avLst/>
+          </a:prstGeom>
+          <a:noFill/>
+        </p:spPr>
+        <p:txBody>
+          <a:bodyPr wrap="square">
+            <a:spAutoFit/>
+          </a:bodyPr>
+          <a:lstStyle/>
+          <a:p>
+            <a:pPr algn="l">
+              <a:spcAft>
+                <a:spcPts val="300"/>
+              </a:spcAft>
+            </a:pPr>
+            <a:r>
+              <a:rPr sz="1100" b="0">
                 <a:solidFill>
                   <a:srgbClr val="0D3B66"/>
                 </a:solidFill>
                 <a:latin typeface="Calibri"/>
               </a:rPr>
-              <a:t>Mantener controles Norte (desde 05/08) y Pizza Hut (desde 01/07). Umbrales 24 h: Norte 40 · Sur 35 · Pizza 50 · Baños 10 m³/día.</a:t>
-            </a:r>
-          </a:p>
-        </p:txBody>
-      </p:sp>
-      <p:sp>
-        <p:nvSpPr>
-          <p:cNvPr id="10" name="Rounded Rectangle 9"/>
+              <a:t>Copiar el on/off que ya corre en Norte y SI500. Meta: esa noche a cero.</a:t>
+            </a:r>
+          </a:p>
+        </p:txBody>
+      </p:sp>
+      <p:sp>
+        <p:nvSpPr>
+          <p:cNvPr id="26" name="Rounded Rectangle 25"/>
           <p:cNvSpPr/>
           <p:nvPr/>
         </p:nvSpPr>
         <p:spPr>
           <a:xfrm>
-            <a:off x="201168" y="1824881"/>
-            <a:ext cx="11777472" cy="773321"/>
+            <a:off x="6309360" y="1682496"/>
+            <a:ext cx="5541264" cy="1115568"/>
           </a:xfrm>
           <a:prstGeom prst="roundRect">
             <a:avLst>
@@ -5769,7 +6433,7 @@
             </a:avLst>
           </a:prstGeom>
           <a:solidFill>
-            <a:srgbClr val="FFF9EB"/>
+            <a:srgbClr val="FFFFFF"/>
           </a:solidFill>
           <a:ln w="6350">
             <a:solidFill>
@@ -5801,14 +6465,14 @@
       </p:sp>
       <p:sp>
         <p:nvSpPr>
-          <p:cNvPr id="11" name="TextBox 10"/>
-          <p:cNvSpPr txBox="1"/>
-          <p:nvPr/>
-        </p:nvSpPr>
-        <p:spPr>
-          <a:xfrm>
-            <a:off x="329184" y="1861457"/>
-            <a:ext cx="11521440" cy="182880"/>
+          <p:cNvPr id="27" name="TextBox 26"/>
+          <p:cNvSpPr txBox="1"/>
+          <p:nvPr/>
+        </p:nvSpPr>
+        <p:spPr>
+          <a:xfrm>
+            <a:off x="6419088" y="1737360"/>
+            <a:ext cx="5321808" cy="219456"/>
           </a:xfrm>
           <a:prstGeom prst="rect">
             <a:avLst/>
@@ -5829,64 +6493,64 @@
             <a:r>
               <a:rPr sz="1200" b="1">
                 <a:solidFill>
-                  <a:srgbClr val="C9A227"/>
-                </a:solidFill>
-                <a:latin typeface="Calibri"/>
-              </a:rPr>
-              <a:t>MAM</a:t>
-            </a:r>
-          </a:p>
-        </p:txBody>
-      </p:sp>
-      <p:sp>
-        <p:nvSpPr>
-          <p:cNvPr id="12" name="TextBox 11"/>
-          <p:cNvSpPr txBox="1"/>
-          <p:nvPr/>
-        </p:nvSpPr>
-        <p:spPr>
-          <a:xfrm>
-            <a:off x="329184" y="2044337"/>
-            <a:ext cx="11521440" cy="499001"/>
-          </a:xfrm>
-          <a:prstGeom prst="rect">
-            <a:avLst/>
-          </a:prstGeom>
-          <a:noFill/>
-        </p:spPr>
-        <p:txBody>
-          <a:bodyPr wrap="square">
-            <a:spAutoFit/>
-          </a:bodyPr>
-          <a:lstStyle/>
-          <a:p>
-            <a:pPr algn="l">
-              <a:spcAft>
-                <a:spcPts val="300"/>
-              </a:spcAft>
-            </a:pPr>
-            <a:r>
-              <a:rPr sz="1200" b="0">
-                <a:solidFill>
                   <a:srgbClr val="0D3B66"/>
                 </a:solidFill>
                 <a:latin typeface="Calibri"/>
               </a:rPr>
-              <a:t>El mall se alimenta por Placa o por Falabella (cuando se inyecta una, se corta la otra). Umbrales 24 h: Placa 290 · Falabella 140 m³/día. Sin on/off hasta ver la noche de la línea que esté inyectando.</a:t>
-            </a:r>
-          </a:p>
-        </p:txBody>
-      </p:sp>
-      <p:sp>
-        <p:nvSpPr>
-          <p:cNvPr id="13" name="Rounded Rectangle 12"/>
+              <a:t>MAQ  ·  Matriz Principal</a:t>
+            </a:r>
+          </a:p>
+        </p:txBody>
+      </p:sp>
+      <p:sp>
+        <p:nvSpPr>
+          <p:cNvPr id="28" name="TextBox 27"/>
+          <p:cNvSpPr txBox="1"/>
+          <p:nvPr/>
+        </p:nvSpPr>
+        <p:spPr>
+          <a:xfrm>
+            <a:off x="6419088" y="1975104"/>
+            <a:ext cx="5321808" cy="749808"/>
+          </a:xfrm>
+          <a:prstGeom prst="rect">
+            <a:avLst/>
+          </a:prstGeom>
+          <a:noFill/>
+        </p:spPr>
+        <p:txBody>
+          <a:bodyPr wrap="square">
+            <a:spAutoFit/>
+          </a:bodyPr>
+          <a:lstStyle/>
+          <a:p>
+            <a:pPr algn="l">
+              <a:spcAft>
+                <a:spcPts val="300"/>
+              </a:spcAft>
+            </a:pPr>
+            <a:r>
+              <a:rPr sz="1100" b="0">
+                <a:solidFill>
+                  <a:srgbClr val="0D3B66"/>
+                </a:solidFill>
+                <a:latin typeface="Calibri"/>
+              </a:rPr>
+              <a:t>On/off 00:30. Noche típica 21,1 m³ → 0 = 634 m³/mes ($887.040). Umbral 24 h: 240 m³/día.</a:t>
+            </a:r>
+          </a:p>
+        </p:txBody>
+      </p:sp>
+      <p:sp>
+        <p:nvSpPr>
+          <p:cNvPr id="29" name="Rounded Rectangle 28"/>
           <p:cNvSpPr/>
           <p:nvPr/>
         </p:nvSpPr>
         <p:spPr>
           <a:xfrm>
-            <a:off x="201168" y="2643922"/>
-            <a:ext cx="11777472" cy="773321"/>
+            <a:off x="6309360" y="2871216"/>
+            <a:ext cx="5541264" cy="1115568"/>
           </a:xfrm>
           <a:prstGeom prst="roundRect">
             <a:avLst>
@@ -5894,7 +6558,7 @@
             </a:avLst>
           </a:prstGeom>
           <a:solidFill>
-            <a:srgbClr val="FFF9EB"/>
+            <a:srgbClr val="FFFFFF"/>
           </a:solidFill>
           <a:ln w="6350">
             <a:solidFill>
@@ -5926,14 +6590,14 @@
       </p:sp>
       <p:sp>
         <p:nvSpPr>
-          <p:cNvPr id="14" name="TextBox 13"/>
-          <p:cNvSpPr txBox="1"/>
-          <p:nvPr/>
-        </p:nvSpPr>
-        <p:spPr>
-          <a:xfrm>
-            <a:off x="329184" y="2680498"/>
-            <a:ext cx="11521440" cy="182880"/>
+          <p:cNvPr id="30" name="TextBox 29"/>
+          <p:cNvSpPr txBox="1"/>
+          <p:nvPr/>
+        </p:nvSpPr>
+        <p:spPr>
+          <a:xfrm>
+            <a:off x="6419088" y="2926080"/>
+            <a:ext cx="5321808" cy="219456"/>
           </a:xfrm>
           <a:prstGeom prst="rect">
             <a:avLst/>
@@ -5954,64 +6618,64 @@
             <a:r>
               <a:rPr sz="1200" b="1">
                 <a:solidFill>
-                  <a:srgbClr val="C9A227"/>
-                </a:solidFill>
-                <a:latin typeface="Calibri"/>
-              </a:rPr>
-              <a:t>MAQ</a:t>
-            </a:r>
-          </a:p>
-        </p:txBody>
-      </p:sp>
-      <p:sp>
-        <p:nvSpPr>
-          <p:cNvPr id="15" name="TextBox 14"/>
-          <p:cNvSpPr txBox="1"/>
-          <p:nvPr/>
-        </p:nvSpPr>
-        <p:spPr>
-          <a:xfrm>
-            <a:off x="329184" y="2863378"/>
-            <a:ext cx="11521440" cy="499001"/>
-          </a:xfrm>
-          <a:prstGeom prst="rect">
-            <a:avLst/>
-          </a:prstGeom>
-          <a:noFill/>
-        </p:spPr>
-        <p:txBody>
-          <a:bodyPr wrap="square">
-            <a:spAutoFit/>
-          </a:bodyPr>
-          <a:lstStyle/>
-          <a:p>
-            <a:pPr algn="l">
-              <a:spcAft>
-                <a:spcPts val="300"/>
-              </a:spcAft>
-            </a:pPr>
-            <a:r>
-              <a:rPr sz="1200" b="0">
-                <a:solidFill>
                   <a:srgbClr val="0D3B66"/>
                 </a:solidFill>
                 <a:latin typeface="Calibri"/>
               </a:rPr>
-              <a:t>Proponer on/off 00–06 en Matriz Principal. Umbral 24 h Matriz 240 m³/día. Alim. Baños no es el punto de control.</a:t>
-            </a:r>
-          </a:p>
-        </p:txBody>
-      </p:sp>
-      <p:sp>
-        <p:nvSpPr>
-          <p:cNvPr id="16" name="Rounded Rectangle 15"/>
+              <a:t>PAK  ·  Bazar Gourmet</a:t>
+            </a:r>
+          </a:p>
+        </p:txBody>
+      </p:sp>
+      <p:sp>
+        <p:nvSpPr>
+          <p:cNvPr id="31" name="TextBox 30"/>
+          <p:cNvSpPr txBox="1"/>
+          <p:nvPr/>
+        </p:nvSpPr>
+        <p:spPr>
+          <a:xfrm>
+            <a:off x="6419088" y="3163824"/>
+            <a:ext cx="5321808" cy="749808"/>
+          </a:xfrm>
+          <a:prstGeom prst="rect">
+            <a:avLst/>
+          </a:prstGeom>
+          <a:noFill/>
+        </p:spPr>
+        <p:txBody>
+          <a:bodyPr wrap="square">
+            <a:spAutoFit/>
+          </a:bodyPr>
+          <a:lstStyle/>
+          <a:p>
+            <a:pPr algn="l">
+              <a:spcAft>
+                <a:spcPts val="300"/>
+              </a:spcAft>
+            </a:pPr>
+            <a:r>
+              <a:rPr sz="1100" b="0">
+                <a:solidFill>
+                  <a:srgbClr val="0D3B66"/>
+                </a:solidFill>
+                <a:latin typeface="Calibri"/>
+              </a:rPr>
+              <a:t>On/off 00:30 en Bazar (no en las Sandías). Noche 29,1 m³ → 0 = 874 m³/mes ($1.224.300). Umbrales: DL 390 · Bazar 250 · DL Kennedy 20.</a:t>
+            </a:r>
+          </a:p>
+        </p:txBody>
+      </p:sp>
+      <p:sp>
+        <p:nvSpPr>
+          <p:cNvPr id="32" name="Rounded Rectangle 31"/>
           <p:cNvSpPr/>
           <p:nvPr/>
         </p:nvSpPr>
         <p:spPr>
           <a:xfrm>
-            <a:off x="201168" y="3462963"/>
-            <a:ext cx="11777472" cy="773321"/>
+            <a:off x="6309360" y="4059936"/>
+            <a:ext cx="5541264" cy="1115568"/>
           </a:xfrm>
           <a:prstGeom prst="roundRect">
             <a:avLst>
@@ -6019,7 +6683,7 @@
             </a:avLst>
           </a:prstGeom>
           <a:solidFill>
-            <a:srgbClr val="FFF9EB"/>
+            <a:srgbClr val="FFFFFF"/>
           </a:solidFill>
           <a:ln w="6350">
             <a:solidFill>
@@ -6051,14 +6715,14 @@
       </p:sp>
       <p:sp>
         <p:nvSpPr>
-          <p:cNvPr id="17" name="TextBox 16"/>
-          <p:cNvSpPr txBox="1"/>
-          <p:nvPr/>
-        </p:nvSpPr>
-        <p:spPr>
-          <a:xfrm>
-            <a:off x="329184" y="3499539"/>
-            <a:ext cx="11521440" cy="182880"/>
+          <p:cNvPr id="33" name="TextBox 32"/>
+          <p:cNvSpPr txBox="1"/>
+          <p:nvPr/>
+        </p:nvSpPr>
+        <p:spPr>
+          <a:xfrm>
+            <a:off x="6419088" y="4114800"/>
+            <a:ext cx="5321808" cy="219456"/>
           </a:xfrm>
           <a:prstGeom prst="rect">
             <a:avLst/>
@@ -6079,64 +6743,64 @@
             <a:r>
               <a:rPr sz="1200" b="1">
                 <a:solidFill>
-                  <a:srgbClr val="C9A227"/>
-                </a:solidFill>
-                <a:latin typeface="Calibri"/>
-              </a:rPr>
-              <a:t>BOM</a:t>
-            </a:r>
-          </a:p>
-        </p:txBody>
-      </p:sp>
-      <p:sp>
-        <p:nvSpPr>
-          <p:cNvPr id="18" name="TextBox 17"/>
-          <p:cNvSpPr txBox="1"/>
-          <p:nvPr/>
-        </p:nvSpPr>
-        <p:spPr>
-          <a:xfrm>
-            <a:off x="329184" y="3682419"/>
-            <a:ext cx="11521440" cy="499001"/>
-          </a:xfrm>
-          <a:prstGeom prst="rect">
-            <a:avLst/>
-          </a:prstGeom>
-          <a:noFill/>
-        </p:spPr>
-        <p:txBody>
-          <a:bodyPr wrap="square">
-            <a:spAutoFit/>
-          </a:bodyPr>
-          <a:lstStyle/>
-          <a:p>
-            <a:pPr algn="l">
-              <a:spcAft>
-                <a:spcPts val="300"/>
-              </a:spcAft>
-            </a:pPr>
-            <a:r>
-              <a:rPr sz="1200" b="0">
-                <a:solidFill>
                   <a:srgbClr val="0D3B66"/>
                 </a:solidFill>
                 <a:latin typeface="Calibri"/>
               </a:rPr>
-              <a:t>Mantener on/off SI500 (desde 17/07). Umbrales: SI500 145 · SI300 45 m³/día.</a:t>
-            </a:r>
-          </a:p>
-        </p:txBody>
-      </p:sp>
-      <p:sp>
-        <p:nvSpPr>
-          <p:cNvPr id="19" name="Rounded Rectangle 18"/>
+              <a:t>AEB  ·  Anillo Plaza y Matriz 1° piso</a:t>
+            </a:r>
+          </a:p>
+        </p:txBody>
+      </p:sp>
+      <p:sp>
+        <p:nvSpPr>
+          <p:cNvPr id="34" name="TextBox 33"/>
+          <p:cNvSpPr txBox="1"/>
+          <p:nvPr/>
+        </p:nvSpPr>
+        <p:spPr>
+          <a:xfrm>
+            <a:off x="6419088" y="4352544"/>
+            <a:ext cx="5321808" cy="749808"/>
+          </a:xfrm>
+          <a:prstGeom prst="rect">
+            <a:avLst/>
+          </a:prstGeom>
+          <a:noFill/>
+        </p:spPr>
+        <p:txBody>
+          <a:bodyPr wrap="square">
+            <a:spAutoFit/>
+          </a:bodyPr>
+          <a:lstStyle/>
+          <a:p>
+            <a:pPr algn="l">
+              <a:spcAft>
+                <a:spcPts val="300"/>
+              </a:spcAft>
+            </a:pPr>
+            <a:r>
+              <a:rPr sz="1100" b="0">
+                <a:solidFill>
+                  <a:srgbClr val="0D3B66"/>
+                </a:solidFill>
+                <a:latin typeface="Calibri"/>
+              </a:rPr>
+              <a:t>Proponer on/off 00:30. Umbrales 24 h: Anillo 22 · Matriz 75 m³/día.</a:t>
+            </a:r>
+          </a:p>
+        </p:txBody>
+      </p:sp>
+      <p:sp>
+        <p:nvSpPr>
+          <p:cNvPr id="35" name="Rounded Rectangle 34"/>
           <p:cNvSpPr/>
           <p:nvPr/>
         </p:nvSpPr>
         <p:spPr>
           <a:xfrm>
-            <a:off x="201168" y="4282004"/>
-            <a:ext cx="11777472" cy="773321"/>
+            <a:off x="6309360" y="5248656"/>
+            <a:ext cx="5541264" cy="1115568"/>
           </a:xfrm>
           <a:prstGeom prst="roundRect">
             <a:avLst>
@@ -6144,7 +6808,7 @@
             </a:avLst>
           </a:prstGeom>
           <a:solidFill>
-            <a:srgbClr val="FFF9EB"/>
+            <a:srgbClr val="FFFFFF"/>
           </a:solidFill>
           <a:ln w="6350">
             <a:solidFill>
@@ -6176,14 +6840,14 @@
       </p:sp>
       <p:sp>
         <p:nvSpPr>
-          <p:cNvPr id="20" name="TextBox 19"/>
-          <p:cNvSpPr txBox="1"/>
-          <p:nvPr/>
-        </p:nvSpPr>
-        <p:spPr>
-          <a:xfrm>
-            <a:off x="329184" y="4318580"/>
-            <a:ext cx="11521440" cy="182880"/>
+          <p:cNvPr id="36" name="TextBox 35"/>
+          <p:cNvSpPr txBox="1"/>
+          <p:nvPr/>
+        </p:nvSpPr>
+        <p:spPr>
+          <a:xfrm>
+            <a:off x="6419088" y="5303520"/>
+            <a:ext cx="5321808" cy="219456"/>
           </a:xfrm>
           <a:prstGeom prst="rect">
             <a:avLst/>
@@ -6204,300 +6868,89 @@
             <a:r>
               <a:rPr sz="1200" b="1">
                 <a:solidFill>
-                  <a:srgbClr val="C9A227"/>
-                </a:solidFill>
-                <a:latin typeface="Calibri"/>
-              </a:rPr>
-              <a:t>AEB</a:t>
-            </a:r>
-          </a:p>
-        </p:txBody>
-      </p:sp>
-      <p:sp>
-        <p:nvSpPr>
-          <p:cNvPr id="21" name="TextBox 20"/>
-          <p:cNvSpPr txBox="1"/>
-          <p:nvPr/>
-        </p:nvSpPr>
-        <p:spPr>
-          <a:xfrm>
-            <a:off x="329184" y="4501460"/>
-            <a:ext cx="11521440" cy="499001"/>
-          </a:xfrm>
-          <a:prstGeom prst="rect">
-            <a:avLst/>
-          </a:prstGeom>
-          <a:noFill/>
-        </p:spPr>
-        <p:txBody>
-          <a:bodyPr wrap="square">
-            <a:spAutoFit/>
-          </a:bodyPr>
-          <a:lstStyle/>
-          <a:p>
-            <a:pPr algn="l">
-              <a:spcAft>
-                <a:spcPts val="300"/>
-              </a:spcAft>
-            </a:pPr>
-            <a:r>
-              <a:rPr sz="1200" b="0">
-                <a:solidFill>
                   <a:srgbClr val="0D3B66"/>
                 </a:solidFill>
                 <a:latin typeface="Calibri"/>
               </a:rPr>
-              <a:t>Proponer on/off 00–06 en Anillo Plaza y Matriz 1° piso. Umbrales: Anillo 22 · Matriz 75 m³/día.</a:t>
-            </a:r>
-          </a:p>
-        </p:txBody>
-      </p:sp>
-      <p:sp>
-        <p:nvSpPr>
-          <p:cNvPr id="22" name="Rounded Rectangle 21"/>
-          <p:cNvSpPr/>
-          <p:nvPr/>
-        </p:nvSpPr>
-        <p:spPr>
-          <a:xfrm>
-            <a:off x="201168" y="5101045"/>
-            <a:ext cx="11777472" cy="773321"/>
-          </a:xfrm>
-          <a:prstGeom prst="roundRect">
-            <a:avLst>
-              <a:gd name="adj" fmla="val 8000"/>
-            </a:avLst>
-          </a:prstGeom>
-          <a:solidFill>
-            <a:srgbClr val="FFF9EB"/>
-          </a:solidFill>
-          <a:ln w="6350">
-            <a:solidFill>
-              <a:srgbClr val="C9A227"/>
-            </a:solidFill>
-          </a:ln>
-        </p:spPr>
-        <p:style>
-          <a:lnRef idx="1">
-            <a:schemeClr val="accent1"/>
-          </a:lnRef>
-          <a:fillRef idx="3">
-            <a:schemeClr val="accent1"/>
-          </a:fillRef>
-          <a:effectRef idx="2">
-            <a:schemeClr val="accent1"/>
-          </a:effectRef>
-          <a:fontRef idx="minor">
-            <a:schemeClr val="lt1"/>
-          </a:fontRef>
-        </p:style>
-        <p:txBody>
-          <a:bodyPr rtlCol="0" anchor="ctr"/>
-          <a:lstStyle/>
-          <a:p>
-            <a:pPr algn="ctr"/>
-          </a:p>
-        </p:txBody>
-      </p:sp>
-      <p:sp>
-        <p:nvSpPr>
-          <p:cNvPr id="23" name="TextBox 22"/>
-          <p:cNvSpPr txBox="1"/>
-          <p:nvPr/>
-        </p:nvSpPr>
-        <p:spPr>
-          <a:xfrm>
-            <a:off x="329184" y="5137621"/>
-            <a:ext cx="11521440" cy="182880"/>
-          </a:xfrm>
-          <a:prstGeom prst="rect">
-            <a:avLst/>
-          </a:prstGeom>
-          <a:noFill/>
-        </p:spPr>
-        <p:txBody>
-          <a:bodyPr wrap="square">
-            <a:spAutoFit/>
-          </a:bodyPr>
-          <a:lstStyle/>
-          <a:p>
-            <a:pPr algn="l">
-              <a:spcAft>
-                <a:spcPts val="300"/>
-              </a:spcAft>
-            </a:pPr>
-            <a:r>
-              <a:rPr sz="1200" b="1">
-                <a:solidFill>
-                  <a:srgbClr val="C9A227"/>
-                </a:solidFill>
-                <a:latin typeface="Calibri"/>
-              </a:rPr>
-              <a:t>CUR</a:t>
-            </a:r>
-          </a:p>
-        </p:txBody>
-      </p:sp>
-      <p:sp>
-        <p:nvSpPr>
-          <p:cNvPr id="24" name="TextBox 23"/>
-          <p:cNvSpPr txBox="1"/>
-          <p:nvPr/>
-        </p:nvSpPr>
-        <p:spPr>
-          <a:xfrm>
-            <a:off x="329184" y="5320501"/>
-            <a:ext cx="11521440" cy="499001"/>
-          </a:xfrm>
-          <a:prstGeom prst="rect">
-            <a:avLst/>
-          </a:prstGeom>
-          <a:noFill/>
-        </p:spPr>
-        <p:txBody>
-          <a:bodyPr wrap="square">
-            <a:spAutoFit/>
-          </a:bodyPr>
-          <a:lstStyle/>
-          <a:p>
-            <a:pPr algn="l">
-              <a:spcAft>
-                <a:spcPts val="300"/>
-              </a:spcAft>
-            </a:pPr>
-            <a:r>
-              <a:rPr sz="1200" b="0">
+              <a:t>MAM / CUR</a:t>
+            </a:r>
+          </a:p>
+        </p:txBody>
+      </p:sp>
+      <p:sp>
+        <p:nvSpPr>
+          <p:cNvPr id="37" name="TextBox 36"/>
+          <p:cNvSpPr txBox="1"/>
+          <p:nvPr/>
+        </p:nvSpPr>
+        <p:spPr>
+          <a:xfrm>
+            <a:off x="6419088" y="5541264"/>
+            <a:ext cx="5321808" cy="749808"/>
+          </a:xfrm>
+          <a:prstGeom prst="rect">
+            <a:avLst/>
+          </a:prstGeom>
+          <a:noFill/>
+        </p:spPr>
+        <p:txBody>
+          <a:bodyPr wrap="square">
+            <a:spAutoFit/>
+          </a:bodyPr>
+          <a:lstStyle/>
+          <a:p>
+            <a:pPr algn="l">
+              <a:spcAft>
+                <a:spcPts val="300"/>
+              </a:spcAft>
+            </a:pPr>
+            <a:r>
+              <a:rPr sz="1100" b="0">
                 <a:solidFill>
                   <a:srgbClr val="0D3B66"/>
                 </a:solidFill>
                 <a:latin typeface="Calibri"/>
               </a:rPr>
-              <a:t>Sin on/off. Umbrales: Anillo Sur 14 · Anillo Norte 13 m³/día.</a:t>
-            </a:r>
-          </a:p>
-        </p:txBody>
-      </p:sp>
-      <p:sp>
-        <p:nvSpPr>
-          <p:cNvPr id="25" name="Rounded Rectangle 24"/>
-          <p:cNvSpPr/>
-          <p:nvPr/>
-        </p:nvSpPr>
-        <p:spPr>
-          <a:xfrm>
-            <a:off x="201168" y="5920086"/>
-            <a:ext cx="11777472" cy="773321"/>
-          </a:xfrm>
-          <a:prstGeom prst="roundRect">
-            <a:avLst>
-              <a:gd name="adj" fmla="val 8000"/>
-            </a:avLst>
-          </a:prstGeom>
-          <a:solidFill>
-            <a:srgbClr val="FFF9EB"/>
-          </a:solidFill>
-          <a:ln w="6350">
-            <a:solidFill>
-              <a:srgbClr val="C9A227"/>
-            </a:solidFill>
-          </a:ln>
-        </p:spPr>
-        <p:style>
-          <a:lnRef idx="1">
-            <a:schemeClr val="accent1"/>
-          </a:lnRef>
-          <a:fillRef idx="3">
-            <a:schemeClr val="accent1"/>
-          </a:fillRef>
-          <a:effectRef idx="2">
-            <a:schemeClr val="accent1"/>
-          </a:effectRef>
-          <a:fontRef idx="minor">
-            <a:schemeClr val="lt1"/>
-          </a:fontRef>
-        </p:style>
-        <p:txBody>
-          <a:bodyPr rtlCol="0" anchor="ctr"/>
-          <a:lstStyle/>
-          <a:p>
-            <a:pPr algn="ctr"/>
-          </a:p>
-        </p:txBody>
-      </p:sp>
-      <p:sp>
-        <p:nvSpPr>
-          <p:cNvPr id="26" name="TextBox 25"/>
-          <p:cNvSpPr txBox="1"/>
-          <p:nvPr/>
-        </p:nvSpPr>
-        <p:spPr>
-          <a:xfrm>
-            <a:off x="329184" y="5956662"/>
-            <a:ext cx="11521440" cy="182880"/>
-          </a:xfrm>
-          <a:prstGeom prst="rect">
-            <a:avLst/>
-          </a:prstGeom>
-          <a:noFill/>
-        </p:spPr>
-        <p:txBody>
-          <a:bodyPr wrap="square">
-            <a:spAutoFit/>
-          </a:bodyPr>
-          <a:lstStyle/>
-          <a:p>
-            <a:pPr algn="l">
-              <a:spcAft>
-                <a:spcPts val="300"/>
-              </a:spcAft>
-            </a:pPr>
-            <a:r>
-              <a:rPr sz="1200" b="1">
-                <a:solidFill>
-                  <a:srgbClr val="C9A227"/>
-                </a:solidFill>
-                <a:latin typeface="Calibri"/>
-              </a:rPr>
-              <a:t>PAK</a:t>
-            </a:r>
-          </a:p>
-        </p:txBody>
-      </p:sp>
-      <p:sp>
-        <p:nvSpPr>
-          <p:cNvPr id="27" name="TextBox 26"/>
-          <p:cNvSpPr txBox="1"/>
-          <p:nvPr/>
-        </p:nvSpPr>
-        <p:spPr>
-          <a:xfrm>
-            <a:off x="329184" y="6139542"/>
-            <a:ext cx="11521440" cy="499001"/>
-          </a:xfrm>
-          <a:prstGeom prst="rect">
-            <a:avLst/>
-          </a:prstGeom>
-          <a:noFill/>
-        </p:spPr>
-        <p:txBody>
-          <a:bodyPr wrap="square">
-            <a:spAutoFit/>
-          </a:bodyPr>
-          <a:lstStyle/>
-          <a:p>
-            <a:pPr algn="l">
-              <a:spcAft>
-                <a:spcPts val="300"/>
-              </a:spcAft>
-            </a:pPr>
-            <a:r>
-              <a:rPr sz="1200" b="0">
+              <a:t>Maipú: sin on/off; a la espera de Arrow + punto 6 (Pasillo 2). Curauma: noche chica, sin on/off. Umbrales Sur 14 · Norte 13.</a:t>
+            </a:r>
+          </a:p>
+        </p:txBody>
+      </p:sp>
+      <p:sp>
+        <p:nvSpPr>
+          <p:cNvPr id="38" name="TextBox 37"/>
+          <p:cNvSpPr txBox="1"/>
+          <p:nvPr/>
+        </p:nvSpPr>
+        <p:spPr>
+          <a:xfrm>
+            <a:off x="6309360" y="6473952"/>
+            <a:ext cx="5559552" cy="146304"/>
+          </a:xfrm>
+          <a:prstGeom prst="rect">
+            <a:avLst/>
+          </a:prstGeom>
+          <a:noFill/>
+        </p:spPr>
+        <p:txBody>
+          <a:bodyPr wrap="square">
+            <a:spAutoFit/>
+          </a:bodyPr>
+          <a:lstStyle/>
+          <a:p>
+            <a:pPr algn="l">
+              <a:spcAft>
+                <a:spcPts val="300"/>
+              </a:spcAft>
+            </a:pPr>
+            <a:r>
+              <a:rPr sz="1100" b="1">
                 <a:solidFill>
                   <a:srgbClr val="0D3B66"/>
                 </a:solidFill>
                 <a:latin typeface="Calibri"/>
               </a:rPr>
-              <a:t>Proponer on/off 00–06 en el eslabón de mayor noche (DL / Bazar). Umbrales: DL 390 · Bazar 250 · DL Kennedy 20 m³/día. Cadena no se suma a cabecera.</a:t>
+              <a:t>Si se aprueban MAQ + PAK: 4.333 m³/mes  ·  $6.066.060</a:t>
             </a:r>
           </a:p>
         </p:txBody>
@@ -8321,7 +8774,7 @@
                 </a:solidFill>
                 <a:latin typeface="Calibri"/>
               </a:rPr>
-              <a:t>7.700</a:t>
+              <a:t>0</a:t>
             </a:r>
           </a:p>
         </p:txBody>
@@ -8407,7 +8860,7 @@
                 </a:solidFill>
                 <a:latin typeface="Calibri"/>
               </a:rPr>
-              <a:t>2.143</a:t>
+              <a:t>0</a:t>
             </a:r>
           </a:p>
         </p:txBody>
@@ -8493,7 +8946,7 @@
                 </a:solidFill>
                 <a:latin typeface="Calibri"/>
               </a:rPr>
-              <a:t>1.897</a:t>
+              <a:t>0</a:t>
             </a:r>
           </a:p>
         </p:txBody>
@@ -8579,7 +9032,7 @@
                 </a:solidFill>
                 <a:latin typeface="Calibri"/>
               </a:rPr>
-              <a:t>1.894</a:t>
+              <a:t>0</a:t>
             </a:r>
           </a:p>
         </p:txBody>
@@ -8665,7 +9118,7 @@
                 </a:solidFill>
                 <a:latin typeface="Calibri"/>
               </a:rPr>
-              <a:t>≈ 0 %</a:t>
+              <a:t>n/d</a:t>
             </a:r>
           </a:p>
         </p:txBody>
@@ -8751,7 +9204,7 @@
                 </a:solidFill>
                 <a:latin typeface="Calibri"/>
               </a:rPr>
-              <a:t>Placa Bancaria  948</a:t>
+              <a:t>Placa Bancaria  0</a:t>
             </a:r>
           </a:p>
         </p:txBody>
@@ -9009,7 +9462,7 @@
                 </a:solidFill>
                 <a:latin typeface="Calibri"/>
               </a:rPr>
-              <a:t>6.189</a:t>
+              <a:t>6.095</a:t>
             </a:r>
           </a:p>
         </p:txBody>
@@ -9095,7 +9548,7 @@
                 </a:solidFill>
                 <a:latin typeface="Calibri"/>
               </a:rPr>
-              <a:t>1.477</a:t>
+              <a:t>1.447</a:t>
             </a:r>
           </a:p>
         </p:txBody>
@@ -9181,7 +9634,7 @@
                 </a:solidFill>
                 <a:latin typeface="Calibri"/>
               </a:rPr>
-              <a:t>1.242</a:t>
+              <a:t>1.218</a:t>
             </a:r>
           </a:p>
         </p:txBody>
@@ -9267,7 +9720,7 @@
                 </a:solidFill>
                 <a:latin typeface="Calibri"/>
               </a:rPr>
-              <a:t>1.290</a:t>
+              <a:t>1.269</a:t>
             </a:r>
           </a:p>
         </p:txBody>
@@ -10385,7 +10838,7 @@
                 </a:solidFill>
                 <a:latin typeface="Calibri"/>
               </a:rPr>
-              <a:t>2.320</a:t>
+              <a:t>0</a:t>
             </a:r>
           </a:p>
         </p:txBody>
@@ -10471,7 +10924,7 @@
                 </a:solidFill>
                 <a:latin typeface="Calibri"/>
               </a:rPr>
-              <a:t>692</a:t>
+              <a:t>0</a:t>
             </a:r>
           </a:p>
         </p:txBody>
@@ -10557,7 +11010,7 @@
                 </a:solidFill>
                 <a:latin typeface="Calibri"/>
               </a:rPr>
-              <a:t>570</a:t>
+              <a:t>0</a:t>
             </a:r>
           </a:p>
         </p:txBody>
@@ -10643,7 +11096,7 @@
                 </a:solidFill>
                 <a:latin typeface="Calibri"/>
               </a:rPr>
-              <a:t>610</a:t>
+              <a:t>0</a:t>
             </a:r>
           </a:p>
         </p:txBody>
@@ -10729,7 +11182,7 @@
                 </a:solidFill>
                 <a:latin typeface="Calibri"/>
               </a:rPr>
-              <a:t>↑ 7 %</a:t>
+              <a:t>n/d</a:t>
             </a:r>
           </a:p>
         </p:txBody>
@@ -10815,7 +11268,7 @@
                 </a:solidFill>
                 <a:latin typeface="Calibri"/>
               </a:rPr>
-              <a:t>Matriz 1° piso  497</a:t>
+              <a:t>Matriz 1° piso  0</a:t>
             </a:r>
           </a:p>
         </p:txBody>
@@ -11073,7 +11526,7 @@
                 </a:solidFill>
                 <a:latin typeface="Calibri"/>
               </a:rPr>
-              <a:t>659</a:t>
+              <a:t>0</a:t>
             </a:r>
           </a:p>
         </p:txBody>
@@ -11159,7 +11612,7 @@
                 </a:solidFill>
                 <a:latin typeface="Calibri"/>
               </a:rPr>
-              <a:t>177</a:t>
+              <a:t>0</a:t>
             </a:r>
           </a:p>
         </p:txBody>
@@ -11245,7 +11698,7 @@
                 </a:solidFill>
                 <a:latin typeface="Calibri"/>
               </a:rPr>
-              <a:t>152</a:t>
+              <a:t>0</a:t>
             </a:r>
           </a:p>
         </p:txBody>
@@ -11331,7 +11784,7 @@
                 </a:solidFill>
                 <a:latin typeface="Calibri"/>
               </a:rPr>
-              <a:t>158</a:t>
+              <a:t>0</a:t>
             </a:r>
           </a:p>
         </p:txBody>
@@ -11417,7 +11870,7 @@
                 </a:solidFill>
                 <a:latin typeface="Calibri"/>
               </a:rPr>
-              <a:t>↑ 4 %</a:t>
+              <a:t>n/d</a:t>
             </a:r>
           </a:p>
         </p:txBody>
@@ -11503,7 +11956,7 @@
                 </a:solidFill>
                 <a:latin typeface="Calibri"/>
               </a:rPr>
-              <a:t>Anillo Sur  80</a:t>
+              <a:t>Anillo Sur  0</a:t>
             </a:r>
           </a:p>
         </p:txBody>
@@ -11761,7 +12214,7 @@
                 </a:solidFill>
                 <a:latin typeface="Calibri"/>
               </a:rPr>
-              <a:t>39.484</a:t>
+              <a:t>0</a:t>
             </a:r>
           </a:p>
         </p:txBody>
@@ -11847,7 +12300,7 @@
                 </a:solidFill>
                 <a:latin typeface="Calibri"/>
               </a:rPr>
-              <a:t>10.586</a:t>
+              <a:t>0</a:t>
             </a:r>
           </a:p>
         </p:txBody>
@@ -11933,7 +12386,7 @@
                 </a:solidFill>
                 <a:latin typeface="Calibri"/>
               </a:rPr>
-              <a:t>9.089</a:t>
+              <a:t>0</a:t>
             </a:r>
           </a:p>
         </p:txBody>
@@ -12019,7 +12472,7 @@
                 </a:solidFill>
                 <a:latin typeface="Calibri"/>
               </a:rPr>
-              <a:t>9.366</a:t>
+              <a:t>0</a:t>
             </a:r>
           </a:p>
         </p:txBody>
@@ -12105,7 +12558,7 @@
                 </a:solidFill>
                 <a:latin typeface="Calibri"/>
               </a:rPr>
-              <a:t>↑ 3 %</a:t>
+              <a:t>n/d</a:t>
             </a:r>
           </a:p>
         </p:txBody>
@@ -12191,7 +12644,7 @@
                 </a:solidFill>
                 <a:latin typeface="Calibri"/>
               </a:rPr>
-              <a:t>Sandía Antigua  3.984</a:t>
+              <a:t>Matriz Andén  0</a:t>
             </a:r>
           </a:p>
         </p:txBody>
@@ -12686,7 +13139,71 @@
                 </a:solidFill>
                 <a:latin typeface="Calibri"/>
               </a:rPr>
-              <a:t>•  MAM: Salida ARROW (000025-33) · residual, no es alerta</a:t>
+              <a:t>•  MAM: Placa Bancaria (000025-08), Falabella (000025-09), Ripley (000025-10), Pasillo Técnico (000025-32) · residual, no es alerta, Salida ARROW (000025-33) · residual, no es alerta</a:t>
+            </a:r>
+          </a:p>
+          <a:p>
+            <a:pPr algn="l">
+              <a:spcAft>
+                <a:spcPts val="300"/>
+              </a:spcAft>
+            </a:pPr>
+            <a:r>
+              <a:rPr sz="1200" b="0">
+                <a:solidFill>
+                  <a:srgbClr val="0D3B66"/>
+                </a:solidFill>
+                <a:latin typeface="Calibri"/>
+              </a:rPr>
+              <a:t>•  MAQ: Alim. Baños (000025-34)</a:t>
+            </a:r>
+          </a:p>
+          <a:p>
+            <a:pPr algn="l">
+              <a:spcAft>
+                <a:spcPts val="300"/>
+              </a:spcAft>
+            </a:pPr>
+            <a:r>
+              <a:rPr sz="1200" b="0">
+                <a:solidFill>
+                  <a:srgbClr val="0D3B66"/>
+                </a:solidFill>
+                <a:latin typeface="Calibri"/>
+              </a:rPr>
+              <a:t>•  AEB: Matriz 1° piso (000025-11), Anillo Plaza (000025-12)</a:t>
+            </a:r>
+          </a:p>
+          <a:p>
+            <a:pPr algn="l">
+              <a:spcAft>
+                <a:spcPts val="300"/>
+              </a:spcAft>
+            </a:pPr>
+            <a:r>
+              <a:rPr sz="1200" b="0">
+                <a:solidFill>
+                  <a:srgbClr val="0D3B66"/>
+                </a:solidFill>
+                <a:latin typeface="Calibri"/>
+              </a:rPr>
+              <a:t>•  CUR: Anillo Sur (000025-37), Anillo Norte (000025-38)</a:t>
+            </a:r>
+          </a:p>
+          <a:p>
+            <a:pPr algn="l">
+              <a:spcAft>
+                <a:spcPts val="300"/>
+              </a:spcAft>
+            </a:pPr>
+            <a:r>
+              <a:rPr sz="1200" b="0">
+                <a:solidFill>
+                  <a:srgbClr val="0D3B66"/>
+                </a:solidFill>
+                <a:latin typeface="Calibri"/>
+              </a:rPr>
+              <a:t>•  PAK: Matriz Andén (000025-20), Locales Gast. (000025-21), Sandía Antigua (000025-22), Pileta (000025-23), Cascada (000025-24), Sandía Nueva (000025-28), Restaurante (000025-29)</a:t>
             </a:r>
           </a:p>
         </p:txBody>
@@ -12798,22 +13315,6 @@
             <a:spAutoFit/>
           </a:bodyPr>
           <a:lstStyle/>
-          <a:p>
-            <a:pPr algn="l">
-              <a:spcAft>
-                <a:spcPts val="400"/>
-              </a:spcAft>
-            </a:pPr>
-            <a:r>
-              <a:rPr sz="1200" b="0">
-                <a:solidFill>
-                  <a:srgbClr val="0D3B66"/>
-                </a:solidFill>
-                <a:latin typeface="Calibri"/>
-              </a:rPr>
-              <a:t>•  MAM: el mall se alimenta por Placa Bancaria o por Falabella (cuando se inyecta una, se corta la otra). El 08/09 sale por Falabella: Placa 4,5 m³ (típico 146) y Falabella 92 m³ (típico 50). No son dos fallas.</a:t>
-            </a:r>
-          </a:p>
           <a:p>
             <a:pPr algn="l">
               <a:spcAft>
@@ -13443,7 +13944,7 @@
                 </a:solidFill>
                 <a:latin typeface="Calibri"/>
               </a:rPr>
-              <a:t>•  Noche 00–06 (suma semana): Estanque Norte 9,9  ·  Pizza Hut 0  ·  Estanque Sur 1 m³.</a:t>
+              <a:t>•  Noche 00–06 (suma semana): Estanque Norte 9,9  ·  Pizza Hut 0  ·  Estanque Sur 0 m³.</a:t>
             </a:r>
           </a:p>
           <a:p>
@@ -14494,7 +14995,7 @@
                 </a:solidFill>
                 <a:latin typeface="Calibri"/>
               </a:rPr>
-              <a:t>•  Semana 02/09–08/09: 1.894 m³ (prom. 270,6 m³/día) · Δ vs previa ≈ 0 %.</a:t>
+              <a:t>•  Semana 02/09–08/09: 0 m³ (prom. 0 m³/día) · Δ vs previa n/d.</a:t>
             </a:r>
           </a:p>
           <a:p>
@@ -14510,7 +15011,7 @@
                 </a:solidFill>
                 <a:latin typeface="Calibri"/>
               </a:rPr>
-              <a:t>•  MAM: el mall se alimenta por Placa Bancaria o por Falabella (cuando se inyecta una, se corta la otra). El 08/09 sale por Falabella: Placa 4,5 m³ (típico 146) y Falabella 92 m³ (típico 50). No son dos fallas.</a:t>
+              <a:t>•  El recinto se alimenta por Placa Bancaria o por Falabella: cuando se inyecta una, se corta la otra. No se leen como dos fallas el mismo día.</a:t>
             </a:r>
           </a:p>
           <a:p>
@@ -14526,7 +15027,7 @@
                 </a:solidFill>
                 <a:latin typeface="Calibri"/>
               </a:rPr>
-              <a:t>•  Mayor aporte de la semana: Placa Bancaria (000025-08) con 948 m³.</a:t>
+              <a:t>•  Mayor aporte de la semana: Placa Bancaria (000025-08) con 0 m³.</a:t>
             </a:r>
           </a:p>
           <a:p>
@@ -14542,7 +15043,7 @@
                 </a:solidFill>
                 <a:latin typeface="Calibri"/>
               </a:rPr>
-              <a:t>•  Noche 00–06 (suma semana): Placa Bancaria 37,7  ·  Falabella 21,3  ·  Ripley 0 m³.</a:t>
+              <a:t>•  Noche 00–06 (suma semana): Placa Bancaria 0  ·  Falabella 0  ·  Ripley 0 m³.</a:t>
             </a:r>
           </a:p>
         </p:txBody>
@@ -14564,7 +15065,7 @@
         <p:spPr>
           <a:xfrm>
             <a:off x="256032" y="2542032"/>
-            <a:ext cx="5806440" cy="2391235"/>
+            <a:ext cx="5806440" cy="2385316"/>
           </a:xfrm>
           <a:prstGeom prst="rect">
             <a:avLst/>
@@ -14715,7 +15216,7 @@
                 </a:solidFill>
                 <a:latin typeface="Calibri"/>
               </a:rPr>
-              <a:t>948 m³</a:t>
+              <a:t>0 m³</a:t>
             </a:r>
           </a:p>
         </p:txBody>
@@ -14879,7 +15380,7 @@
                 </a:solidFill>
                 <a:latin typeface="Calibri"/>
               </a:rPr>
-              <a:t>572 m³</a:t>
+              <a:t>0 m³</a:t>
             </a:r>
           </a:p>
         </p:txBody>
@@ -15043,7 +15544,7 @@
                 </a:solidFill>
                 <a:latin typeface="Calibri"/>
               </a:rPr>
-              <a:t>370 m³</a:t>
+              <a:t>0 m³</a:t>
             </a:r>
           </a:p>
         </p:txBody>
@@ -15207,7 +15708,7 @@
                 </a:solidFill>
                 <a:latin typeface="Calibri"/>
               </a:rPr>
-              <a:t>5 m³</a:t>
+              <a:t>0 m³</a:t>
             </a:r>
           </a:p>
         </p:txBody>
@@ -15741,7 +16242,7 @@
                 </a:solidFill>
                 <a:latin typeface="Calibri"/>
               </a:rPr>
-              <a:t>•  Semana 02/09–08/09: 1.290 m³ (prom. 184,3 m³/día) · Δ vs previa ↑ 4 %.</a:t>
+              <a:t>•  Semana 02/09–08/09: 1.269 m³ (prom. 181,3 m³/día) · Δ vs previa ↑ 4 %.</a:t>
             </a:r>
           </a:p>
           <a:p>
@@ -16126,7 +16627,7 @@
                 </a:solidFill>
                 <a:latin typeface="Calibri"/>
               </a:rPr>
-              <a:t>21 m³</a:t>
+              <a:t>0 m³</a:t>
             </a:r>
           </a:p>
         </p:txBody>
@@ -17251,7 +17752,7 @@
                 </a:solidFill>
                 <a:latin typeface="Calibri"/>
               </a:rPr>
-              <a:t>•  Semana 02/09–08/09: 610 m³ (prom. 87,2 m³/día) · Δ vs previa ↑ 7 %.</a:t>
+              <a:t>•  Semana 02/09–08/09: 0 m³ (prom. 0 m³/día) · Δ vs previa n/d.</a:t>
             </a:r>
           </a:p>
           <a:p>
@@ -17267,7 +17768,7 @@
                 </a:solidFill>
                 <a:latin typeface="Calibri"/>
               </a:rPr>
-              <a:t>•  Mayor aporte de la semana: Matriz 1° piso (000025-11) con 497 m³.</a:t>
+              <a:t>•  Mayor aporte de la semana: Matriz 1° piso (000025-11) con 0 m³.</a:t>
             </a:r>
           </a:p>
           <a:p>
@@ -17283,7 +17784,7 @@
                 </a:solidFill>
                 <a:latin typeface="Calibri"/>
               </a:rPr>
-              <a:t>•  Noche 00–06 (suma semana): Matriz 1° piso 55,4  ·  Anillo Plaza 29,4 m³.</a:t>
+              <a:t>•  Noche 00–06 (suma semana): Matriz 1° piso 0  ·  Anillo Plaza 0 m³.</a:t>
             </a:r>
           </a:p>
           <a:p>
@@ -17306,7 +17807,7 @@
       </p:sp>
       <p:pic>
         <p:nvPicPr>
-          <p:cNvPr id="10" name="Picture 9" descr="mensual_AEB.png"/>
+          <p:cNvPr id="10" name="Picture 9" descr="mensual_MAM.png"/>
           <p:cNvPicPr>
             <a:picLocks noChangeAspect="1"/>
           </p:cNvPicPr>
@@ -17321,7 +17822,7 @@
         <p:spPr>
           <a:xfrm>
             <a:off x="256032" y="2542032"/>
-            <a:ext cx="5806440" cy="2391235"/>
+            <a:ext cx="5806440" cy="2385316"/>
           </a:xfrm>
           <a:prstGeom prst="rect">
             <a:avLst/>
@@ -17472,7 +17973,7 @@
                 </a:solidFill>
                 <a:latin typeface="Calibri"/>
               </a:rPr>
-              <a:t>497 m³</a:t>
+              <a:t>0 m³</a:t>
             </a:r>
           </a:p>
         </p:txBody>
@@ -17636,7 +18137,7 @@
                 </a:solidFill>
                 <a:latin typeface="Calibri"/>
               </a:rPr>
-              <a:t>113 m³</a:t>
+              <a:t>0 m³</a:t>
             </a:r>
           </a:p>
         </p:txBody>
@@ -18006,7 +18507,7 @@
                 </a:solidFill>
                 <a:latin typeface="Calibri"/>
               </a:rPr>
-              <a:t>•  Semana 02/09–08/09: 158 m³ (prom. 22,6 m³/día) · Δ vs previa ↑ 4 %.</a:t>
+              <a:t>•  Semana 02/09–08/09: 0 m³ (prom. 0 m³/día) · Δ vs previa n/d.</a:t>
             </a:r>
           </a:p>
           <a:p>
@@ -18022,7 +18523,7 @@
                 </a:solidFill>
                 <a:latin typeface="Calibri"/>
               </a:rPr>
-              <a:t>•  Mayor aporte de la semana: Anillo Sur (000025-37) con 80 m³.</a:t>
+              <a:t>•  Mayor aporte de la semana: Anillo Sur (000025-37) con 0 m³.</a:t>
             </a:r>
           </a:p>
           <a:p>
@@ -18038,7 +18539,7 @@
                 </a:solidFill>
                 <a:latin typeface="Calibri"/>
               </a:rPr>
-              <a:t>•  Noche 00–06 (suma semana): Anillo Sur 5,3  ·  Anillo Norte 3,2 m³.</a:t>
+              <a:t>•  Noche 00–06 (suma semana): Anillo Sur 0  ·  Anillo Norte 0 m³.</a:t>
             </a:r>
           </a:p>
           <a:p>
@@ -18054,14 +18555,14 @@
                 </a:solidFill>
                 <a:latin typeface="Calibri"/>
               </a:rPr>
-              <a:t>•  Agosto 659 m³  ·  septiembre 1–8 177 m³ (22,1 m³/día).</a:t>
+              <a:t>•  Cambio de monitoreo: Anillo Norte y Sur desde el 19/05 (mayo no se grafica). Lámina 2: diferencia, noche y umbral.</a:t>
             </a:r>
           </a:p>
         </p:txBody>
       </p:sp>
       <p:pic>
         <p:nvPicPr>
-          <p:cNvPr id="10" name="Picture 9" descr="mensual_CUR.png"/>
+          <p:cNvPr id="10" name="Picture 9" descr="mensual_MAM.png"/>
           <p:cNvPicPr>
             <a:picLocks noChangeAspect="1"/>
           </p:cNvPicPr>
@@ -18076,7 +18577,7 @@
         <p:spPr>
           <a:xfrm>
             <a:off x="256032" y="2542032"/>
-            <a:ext cx="5806440" cy="2391235"/>
+            <a:ext cx="5806440" cy="2385316"/>
           </a:xfrm>
           <a:prstGeom prst="rect">
             <a:avLst/>
@@ -18227,7 +18728,7 @@
                 </a:solidFill>
                 <a:latin typeface="Calibri"/>
               </a:rPr>
-              <a:t>78 m³</a:t>
+              <a:t>0 m³</a:t>
             </a:r>
           </a:p>
         </p:txBody>
@@ -18391,7 +18892,7 @@
                 </a:solidFill>
                 <a:latin typeface="Calibri"/>
               </a:rPr>
-              <a:t>80 m³</a:t>
+              <a:t>0 m³</a:t>
             </a:r>
           </a:p>
         </p:txBody>

</xml_diff>

<commit_message>
Regenerate PA meeting brief and consolidado with AEB and Falabella night savings.
El Bosque Matriz 1° piso and Maipú Falabella now carry m³/$ in the 00:30-to-zero simulation (205 and 249 m³/mes through 08/09/2026).

Co-authored-by: anibaloperacionesWes <anibaloperacionesWes@users.noreply.github.com>
</commit_message>
<xml_diff>
--- a/reports/Parque_Arauco/CONSOLIDADO/Consolidado_PA_7malls_20260908.pptx
+++ b/reports/Parque_Arauco/CONSOLIDADO/Consolidado_PA_7malls_20260908.pptx
@@ -6530,7 +6530,7 @@
               </a:spcAft>
             </a:pPr>
             <a:r>
-              <a:rPr sz="1100" b="0">
+              <a:rPr sz="1000" b="0">
                 <a:solidFill>
                   <a:srgbClr val="0D3B66"/>
                 </a:solidFill>
@@ -6655,7 +6655,7 @@
               </a:spcAft>
             </a:pPr>
             <a:r>
-              <a:rPr sz="1100" b="0">
+              <a:rPr sz="1000" b="0">
                 <a:solidFill>
                   <a:srgbClr val="0D3B66"/>
                 </a:solidFill>
@@ -6747,7 +6747,7 @@
                 </a:solidFill>
                 <a:latin typeface="Calibri"/>
               </a:rPr>
-              <a:t>AEB  ·  Anillo Plaza y Matriz 1° piso</a:t>
+              <a:t>AEB  ·  Matriz 1° piso</a:t>
             </a:r>
           </a:p>
         </p:txBody>
@@ -6780,13 +6780,13 @@
               </a:spcAft>
             </a:pPr>
             <a:r>
-              <a:rPr sz="1100" b="0">
+              <a:rPr sz="1000" b="0">
                 <a:solidFill>
                   <a:srgbClr val="0D3B66"/>
                 </a:solidFill>
                 <a:latin typeface="Calibri"/>
               </a:rPr>
-              <a:t>Proponer on/off 00:30. Umbrales 24 h: Anillo 22 · Matriz 75 m³/día.</a:t>
+              <a:t>On/off 00:30 en el primer piso (no Anillo). Noche 6,8 m³ → 0 = 205 m³/mes ($286.860). Umbral 24 h: 75 m³/día.</a:t>
             </a:r>
           </a:p>
         </p:txBody>
@@ -6872,7 +6872,7 @@
                 </a:solidFill>
                 <a:latin typeface="Calibri"/>
               </a:rPr>
-              <a:t>MAM / CUR</a:t>
+              <a:t>MAM  ·  Falabella</a:t>
             </a:r>
           </a:p>
         </p:txBody>
@@ -6905,13 +6905,13 @@
               </a:spcAft>
             </a:pPr>
             <a:r>
-              <a:rPr sz="1100" b="0">
+              <a:rPr sz="1000" b="0">
                 <a:solidFill>
                   <a:srgbClr val="0D3B66"/>
                 </a:solidFill>
                 <a:latin typeface="Calibri"/>
               </a:rPr>
-              <a:t>Maipú: sin on/off; a la espera de Arrow + punto 6 (Pasillo 2). Curauma: noche chica, sin on/off. Umbrales Sur 14 · Norte 13.</a:t>
+              <a:t>On/off 00:30 (el mall sale por Falabella desde el 15/08). Noche 8,3 m³ → 0 = 249 m³/mes ($348.390). Umbral 140 m³/día. Arrow + punto 6 sigue.</a:t>
             </a:r>
           </a:p>
         </p:txBody>
@@ -6950,7 +6950,7 @@
                 </a:solidFill>
                 <a:latin typeface="Calibri"/>
               </a:rPr>
-              <a:t>Si se aprueban MAQ + PAK: 4.333 m³/mes  ·  $6.066.060</a:t>
+              <a:t>Si se aprueban las 4: 4.787 m³/mes  ·  $6.701.590</a:t>
             </a:r>
           </a:p>
         </p:txBody>

</xml_diff>

<commit_message>
Regenerate PA brief and consolidado with DL Kennedy in the night simulation.
Bazar Gourmet and DL Kennedy now both carry m³/$ (874 and 27 m³/mes through 08/09/2026).

Co-authored-by: anibaloperacionesWes <anibaloperacionesWes@users.noreply.github.com>
</commit_message>
<xml_diff>
--- a/reports/Parque_Arauco/CONSOLIDADO/Consolidado_PA_7malls_20260908.pptx
+++ b/reports/Parque_Arauco/CONSOLIDADO/Consolidado_PA_7malls_20260908.pptx
@@ -6424,8 +6424,8 @@
         </p:nvSpPr>
         <p:spPr>
           <a:xfrm>
-            <a:off x="6309360" y="1682496"/>
-            <a:ext cx="5541264" cy="1115568"/>
+            <a:off x="6309360" y="1627632"/>
+            <a:ext cx="5541264" cy="896112"/>
           </a:xfrm>
           <a:prstGeom prst="roundRect">
             <a:avLst>
@@ -6471,27 +6471,27 @@
         </p:nvSpPr>
         <p:spPr>
           <a:xfrm>
-            <a:off x="6419088" y="1737360"/>
-            <a:ext cx="5321808" cy="219456"/>
-          </a:xfrm>
-          <a:prstGeom prst="rect">
-            <a:avLst/>
-          </a:prstGeom>
-          <a:noFill/>
-        </p:spPr>
-        <p:txBody>
-          <a:bodyPr wrap="square">
-            <a:spAutoFit/>
-          </a:bodyPr>
-          <a:lstStyle/>
-          <a:p>
-            <a:pPr algn="l">
-              <a:spcAft>
-                <a:spcPts val="300"/>
-              </a:spcAft>
-            </a:pPr>
-            <a:r>
-              <a:rPr sz="1200" b="1">
+            <a:off x="6419088" y="1664208"/>
+            <a:ext cx="5321808" cy="201168"/>
+          </a:xfrm>
+          <a:prstGeom prst="rect">
+            <a:avLst/>
+          </a:prstGeom>
+          <a:noFill/>
+        </p:spPr>
+        <p:txBody>
+          <a:bodyPr wrap="square">
+            <a:spAutoFit/>
+          </a:bodyPr>
+          <a:lstStyle/>
+          <a:p>
+            <a:pPr algn="l">
+              <a:spcAft>
+                <a:spcPts val="300"/>
+              </a:spcAft>
+            </a:pPr>
+            <a:r>
+              <a:rPr sz="1100" b="1">
                 <a:solidFill>
                   <a:srgbClr val="0D3B66"/>
                 </a:solidFill>
@@ -6510,8 +6510,8 @@
         </p:nvSpPr>
         <p:spPr>
           <a:xfrm>
-            <a:off x="6419088" y="1975104"/>
-            <a:ext cx="5321808" cy="749808"/>
+            <a:off x="6419088" y="1865376"/>
+            <a:ext cx="5321808" cy="621792"/>
           </a:xfrm>
           <a:prstGeom prst="rect">
             <a:avLst/>
@@ -6536,7 +6536,7 @@
                 </a:solidFill>
                 <a:latin typeface="Calibri"/>
               </a:rPr>
-              <a:t>On/off 00:30. Noche típica 21,1 m³ → 0 = 634 m³/mes ($887.040). Umbral 24 h: 240 m³/día.</a:t>
+              <a:t>On/off 00:30. Noche 21,1 m³ → 0 = 634 m³/mes ($887.040). Umbral 24 h: 240 m³/día.</a:t>
             </a:r>
           </a:p>
         </p:txBody>
@@ -6549,8 +6549,8 @@
         </p:nvSpPr>
         <p:spPr>
           <a:xfrm>
-            <a:off x="6309360" y="2871216"/>
-            <a:ext cx="5541264" cy="1115568"/>
+            <a:off x="6309360" y="2578608"/>
+            <a:ext cx="5541264" cy="896112"/>
           </a:xfrm>
           <a:prstGeom prst="roundRect">
             <a:avLst>
@@ -6596,27 +6596,27 @@
         </p:nvSpPr>
         <p:spPr>
           <a:xfrm>
-            <a:off x="6419088" y="2926080"/>
-            <a:ext cx="5321808" cy="219456"/>
-          </a:xfrm>
-          <a:prstGeom prst="rect">
-            <a:avLst/>
-          </a:prstGeom>
-          <a:noFill/>
-        </p:spPr>
-        <p:txBody>
-          <a:bodyPr wrap="square">
-            <a:spAutoFit/>
-          </a:bodyPr>
-          <a:lstStyle/>
-          <a:p>
-            <a:pPr algn="l">
-              <a:spcAft>
-                <a:spcPts val="300"/>
-              </a:spcAft>
-            </a:pPr>
-            <a:r>
-              <a:rPr sz="1200" b="1">
+            <a:off x="6419088" y="2615184"/>
+            <a:ext cx="5321808" cy="201168"/>
+          </a:xfrm>
+          <a:prstGeom prst="rect">
+            <a:avLst/>
+          </a:prstGeom>
+          <a:noFill/>
+        </p:spPr>
+        <p:txBody>
+          <a:bodyPr wrap="square">
+            <a:spAutoFit/>
+          </a:bodyPr>
+          <a:lstStyle/>
+          <a:p>
+            <a:pPr algn="l">
+              <a:spcAft>
+                <a:spcPts val="300"/>
+              </a:spcAft>
+            </a:pPr>
+            <a:r>
+              <a:rPr sz="1100" b="1">
                 <a:solidFill>
                   <a:srgbClr val="0D3B66"/>
                 </a:solidFill>
@@ -6635,8 +6635,8 @@
         </p:nvSpPr>
         <p:spPr>
           <a:xfrm>
-            <a:off x="6419088" y="3163824"/>
-            <a:ext cx="5321808" cy="749808"/>
+            <a:off x="6419088" y="2816352"/>
+            <a:ext cx="5321808" cy="621792"/>
           </a:xfrm>
           <a:prstGeom prst="rect">
             <a:avLst/>
@@ -6661,7 +6661,7 @@
                 </a:solidFill>
                 <a:latin typeface="Calibri"/>
               </a:rPr>
-              <a:t>On/off 00:30 en Bazar (no en las Sandías). Noche 29,1 m³ → 0 = 874 m³/mes ($1.224.300). Umbrales: DL 390 · Bazar 250 · DL Kennedy 20.</a:t>
+              <a:t>On/off 00:30 (no las Sandías). Noche 29,1 m³ → 0 = 874 m³/mes ($1.224.300). Umbral 24 h: 250 m³/día.</a:t>
             </a:r>
           </a:p>
         </p:txBody>
@@ -6674,8 +6674,8 @@
         </p:nvSpPr>
         <p:spPr>
           <a:xfrm>
-            <a:off x="6309360" y="4059936"/>
-            <a:ext cx="5541264" cy="1115568"/>
+            <a:off x="6309360" y="3529584"/>
+            <a:ext cx="5541264" cy="896112"/>
           </a:xfrm>
           <a:prstGeom prst="roundRect">
             <a:avLst>
@@ -6721,33 +6721,33 @@
         </p:nvSpPr>
         <p:spPr>
           <a:xfrm>
-            <a:off x="6419088" y="4114800"/>
-            <a:ext cx="5321808" cy="219456"/>
-          </a:xfrm>
-          <a:prstGeom prst="rect">
-            <a:avLst/>
-          </a:prstGeom>
-          <a:noFill/>
-        </p:spPr>
-        <p:txBody>
-          <a:bodyPr wrap="square">
-            <a:spAutoFit/>
-          </a:bodyPr>
-          <a:lstStyle/>
-          <a:p>
-            <a:pPr algn="l">
-              <a:spcAft>
-                <a:spcPts val="300"/>
-              </a:spcAft>
-            </a:pPr>
-            <a:r>
-              <a:rPr sz="1200" b="1">
+            <a:off x="6419088" y="3566160"/>
+            <a:ext cx="5321808" cy="201168"/>
+          </a:xfrm>
+          <a:prstGeom prst="rect">
+            <a:avLst/>
+          </a:prstGeom>
+          <a:noFill/>
+        </p:spPr>
+        <p:txBody>
+          <a:bodyPr wrap="square">
+            <a:spAutoFit/>
+          </a:bodyPr>
+          <a:lstStyle/>
+          <a:p>
+            <a:pPr algn="l">
+              <a:spcAft>
+                <a:spcPts val="300"/>
+              </a:spcAft>
+            </a:pPr>
+            <a:r>
+              <a:rPr sz="1100" b="1">
                 <a:solidFill>
                   <a:srgbClr val="0D3B66"/>
                 </a:solidFill>
                 <a:latin typeface="Calibri"/>
               </a:rPr>
-              <a:t>AEB  ·  Matriz 1° piso</a:t>
+              <a:t>PAK  ·  DL Kennedy</a:t>
             </a:r>
           </a:p>
         </p:txBody>
@@ -6760,8 +6760,8 @@
         </p:nvSpPr>
         <p:spPr>
           <a:xfrm>
-            <a:off x="6419088" y="4352544"/>
-            <a:ext cx="5321808" cy="749808"/>
+            <a:off x="6419088" y="3767328"/>
+            <a:ext cx="5321808" cy="621792"/>
           </a:xfrm>
           <a:prstGeom prst="rect">
             <a:avLst/>
@@ -6786,7 +6786,7 @@
                 </a:solidFill>
                 <a:latin typeface="Calibri"/>
               </a:rPr>
-              <a:t>On/off 00:30 en el primer piso (no Anillo). Noche 6,8 m³ → 0 = 205 m³/mes ($286.860). Umbral 24 h: 75 m³/día.</a:t>
+              <a:t>On/off 00:30 (no las Sandías). Noche 0,9 m³ → 0 = 27 m³/mes ($37.800). Umbral 24 h: 20 m³/día.</a:t>
             </a:r>
           </a:p>
         </p:txBody>
@@ -6799,8 +6799,8 @@
         </p:nvSpPr>
         <p:spPr>
           <a:xfrm>
-            <a:off x="6309360" y="5248656"/>
-            <a:ext cx="5541264" cy="1115568"/>
+            <a:off x="6309360" y="4480560"/>
+            <a:ext cx="5541264" cy="896112"/>
           </a:xfrm>
           <a:prstGeom prst="roundRect">
             <a:avLst>
@@ -6846,32 +6846,157 @@
         </p:nvSpPr>
         <p:spPr>
           <a:xfrm>
-            <a:off x="6419088" y="5303520"/>
-            <a:ext cx="5321808" cy="219456"/>
-          </a:xfrm>
-          <a:prstGeom prst="rect">
-            <a:avLst/>
-          </a:prstGeom>
-          <a:noFill/>
-        </p:spPr>
-        <p:txBody>
-          <a:bodyPr wrap="square">
-            <a:spAutoFit/>
-          </a:bodyPr>
-          <a:lstStyle/>
-          <a:p>
-            <a:pPr algn="l">
-              <a:spcAft>
-                <a:spcPts val="300"/>
-              </a:spcAft>
-            </a:pPr>
-            <a:r>
-              <a:rPr sz="1200" b="1">
+            <a:off x="6419088" y="4517136"/>
+            <a:ext cx="5321808" cy="201168"/>
+          </a:xfrm>
+          <a:prstGeom prst="rect">
+            <a:avLst/>
+          </a:prstGeom>
+          <a:noFill/>
+        </p:spPr>
+        <p:txBody>
+          <a:bodyPr wrap="square">
+            <a:spAutoFit/>
+          </a:bodyPr>
+          <a:lstStyle/>
+          <a:p>
+            <a:pPr algn="l">
+              <a:spcAft>
+                <a:spcPts val="300"/>
+              </a:spcAft>
+            </a:pPr>
+            <a:r>
+              <a:rPr sz="1100" b="1">
                 <a:solidFill>
                   <a:srgbClr val="0D3B66"/>
                 </a:solidFill>
                 <a:latin typeface="Calibri"/>
               </a:rPr>
+              <a:t>AEB  ·  Matriz 1° piso</a:t>
+            </a:r>
+          </a:p>
+        </p:txBody>
+      </p:sp>
+      <p:sp>
+        <p:nvSpPr>
+          <p:cNvPr id="37" name="TextBox 36"/>
+          <p:cNvSpPr txBox="1"/>
+          <p:nvPr/>
+        </p:nvSpPr>
+        <p:spPr>
+          <a:xfrm>
+            <a:off x="6419088" y="4718304"/>
+            <a:ext cx="5321808" cy="621792"/>
+          </a:xfrm>
+          <a:prstGeom prst="rect">
+            <a:avLst/>
+          </a:prstGeom>
+          <a:noFill/>
+        </p:spPr>
+        <p:txBody>
+          <a:bodyPr wrap="square">
+            <a:spAutoFit/>
+          </a:bodyPr>
+          <a:lstStyle/>
+          <a:p>
+            <a:pPr algn="l">
+              <a:spcAft>
+                <a:spcPts val="300"/>
+              </a:spcAft>
+            </a:pPr>
+            <a:r>
+              <a:rPr sz="1000" b="0">
+                <a:solidFill>
+                  <a:srgbClr val="0D3B66"/>
+                </a:solidFill>
+                <a:latin typeface="Calibri"/>
+              </a:rPr>
+              <a:t>On/off 00:30 en el primer piso (no Anillo). Noche 6,8 m³ → 0 = 205 m³/mes ($286.860). Umbral 24 h: 75 m³/día.</a:t>
+            </a:r>
+          </a:p>
+        </p:txBody>
+      </p:sp>
+      <p:sp>
+        <p:nvSpPr>
+          <p:cNvPr id="38" name="Rounded Rectangle 37"/>
+          <p:cNvSpPr/>
+          <p:nvPr/>
+        </p:nvSpPr>
+        <p:spPr>
+          <a:xfrm>
+            <a:off x="6309360" y="5431536"/>
+            <a:ext cx="5541264" cy="896112"/>
+          </a:xfrm>
+          <a:prstGeom prst="roundRect">
+            <a:avLst>
+              <a:gd name="adj" fmla="val 8000"/>
+            </a:avLst>
+          </a:prstGeom>
+          <a:solidFill>
+            <a:srgbClr val="FFFFFF"/>
+          </a:solidFill>
+          <a:ln w="6350">
+            <a:solidFill>
+              <a:srgbClr val="C9A227"/>
+            </a:solidFill>
+          </a:ln>
+        </p:spPr>
+        <p:style>
+          <a:lnRef idx="1">
+            <a:schemeClr val="accent1"/>
+          </a:lnRef>
+          <a:fillRef idx="3">
+            <a:schemeClr val="accent1"/>
+          </a:fillRef>
+          <a:effectRef idx="2">
+            <a:schemeClr val="accent1"/>
+          </a:effectRef>
+          <a:fontRef idx="minor">
+            <a:schemeClr val="lt1"/>
+          </a:fontRef>
+        </p:style>
+        <p:txBody>
+          <a:bodyPr rtlCol="0" anchor="ctr"/>
+          <a:lstStyle/>
+          <a:p>
+            <a:pPr algn="ctr"/>
+          </a:p>
+        </p:txBody>
+      </p:sp>
+      <p:sp>
+        <p:nvSpPr>
+          <p:cNvPr id="39" name="TextBox 38"/>
+          <p:cNvSpPr txBox="1"/>
+          <p:nvPr/>
+        </p:nvSpPr>
+        <p:spPr>
+          <a:xfrm>
+            <a:off x="6419088" y="5468112"/>
+            <a:ext cx="5321808" cy="201168"/>
+          </a:xfrm>
+          <a:prstGeom prst="rect">
+            <a:avLst/>
+          </a:prstGeom>
+          <a:noFill/>
+        </p:spPr>
+        <p:txBody>
+          <a:bodyPr wrap="square">
+            <a:spAutoFit/>
+          </a:bodyPr>
+          <a:lstStyle/>
+          <a:p>
+            <a:pPr algn="l">
+              <a:spcAft>
+                <a:spcPts val="300"/>
+              </a:spcAft>
+            </a:pPr>
+            <a:r>
+              <a:rPr sz="1100" b="1">
+                <a:solidFill>
+                  <a:srgbClr val="0D3B66"/>
+                </a:solidFill>
+                <a:latin typeface="Calibri"/>
+              </a:rPr>
               <a:t>MAM  ·  Falabella</a:t>
             </a:r>
           </a:p>
@@ -6879,14 +7004,14 @@
       </p:sp>
       <p:sp>
         <p:nvSpPr>
-          <p:cNvPr id="37" name="TextBox 36"/>
-          <p:cNvSpPr txBox="1"/>
-          <p:nvPr/>
-        </p:nvSpPr>
-        <p:spPr>
-          <a:xfrm>
-            <a:off x="6419088" y="5541264"/>
-            <a:ext cx="5321808" cy="749808"/>
+          <p:cNvPr id="40" name="TextBox 39"/>
+          <p:cNvSpPr txBox="1"/>
+          <p:nvPr/>
+        </p:nvSpPr>
+        <p:spPr>
+          <a:xfrm>
+            <a:off x="6419088" y="5669280"/>
+            <a:ext cx="5321808" cy="621792"/>
           </a:xfrm>
           <a:prstGeom prst="rect">
             <a:avLst/>
@@ -6911,14 +7036,14 @@
                 </a:solidFill>
                 <a:latin typeface="Calibri"/>
               </a:rPr>
-              <a:t>On/off 00:30 (el mall sale por Falabella desde el 15/08). Noche 8,3 m³ → 0 = 249 m³/mes ($348.390). Umbral 140 m³/día. Arrow + punto 6 sigue.</a:t>
-            </a:r>
-          </a:p>
-        </p:txBody>
-      </p:sp>
-      <p:sp>
-        <p:nvSpPr>
-          <p:cNvPr id="38" name="TextBox 37"/>
+              <a:t>On/off 00:30 (sale por Falabella desde el 15/08). Noche 8,3 m³ → 0 = 249 m³/mes ($348.390). Umbral 140 m³/día.</a:t>
+            </a:r>
+          </a:p>
+        </p:txBody>
+      </p:sp>
+      <p:sp>
+        <p:nvSpPr>
+          <p:cNvPr id="41" name="TextBox 40"/>
           <p:cNvSpPr txBox="1"/>
           <p:nvPr/>
         </p:nvSpPr>
@@ -6950,7 +7075,7 @@
                 </a:solidFill>
                 <a:latin typeface="Calibri"/>
               </a:rPr>
-              <a:t>Si se aprueban las 4: 4.787 m³/mes  ·  $6.701.590</a:t>
+              <a:t>Si se aprueban las 5: 4.814 m³/mes  ·  $6.739.390</a:t>
             </a:r>
           </a:p>
         </p:txBody>

</xml_diff>

<commit_message>
fix(pa): Sur fuera de la suma; Andén 3-4 reemplaza DL Kennedy
Estanque Sur queda como contexto (presostato al relocalizar), no como
control WES. La propuesta de Kennedy pasa a Andén 3-4 Matriz. Gráfico
de barras de los cinco futuros puntos de control.

Co-authored-by: anibaloperacionesWes <anibaloperacionesWes@users.noreply.github.com>
</commit_message>
<xml_diff>
--- a/reports/Parque_Arauco/CONSOLIDADO/Consolidado_PA_7malls_20260908.pptx
+++ b/reports/Parque_Arauco/CONSOLIDADO/Consolidado_PA_7malls_20260908.pptx
@@ -16,6 +16,7 @@
     <p:sldId id="264" r:id="rId15"/>
     <p:sldId id="265" r:id="rId16"/>
     <p:sldId id="266" r:id="rId17"/>
+    <p:sldId id="267" r:id="rId18"/>
   </p:sldIdLst>
   <p:sldSz cx="12191695" cy="6858000" type="screen4x3"/>
   <p:notesSz cx="6858000" cy="9144000"/>
@@ -3680,7 +3681,7 @@
                 </a:solidFill>
                 <a:latin typeface="Calibri"/>
               </a:rPr>
-              <a:t>•  Semana 02/09–08/09: 0 m³ (prom. 0 m³/día) · Δ vs previa n/d.</a:t>
+              <a:t>•  Semana 02/09–08/09: 706 m³ (prom. 100,8 m³/día) · Δ vs previa ↓ 2 %.</a:t>
             </a:r>
           </a:p>
           <a:p>
@@ -3712,7 +3713,7 @@
                 </a:solidFill>
                 <a:latin typeface="Calibri"/>
               </a:rPr>
-              <a:t>•  Noche 00–06 (suma semana): Distrito Lujo 325,3  ·  Bazar Gourmet 231,3  ·  DL Kennedy 5,2 m³.</a:t>
+              <a:t>•  Noche 00–06 (suma semana): Distrito Lujo 325,3  ·  Bazar Gourmet 231,3  ·  DL Kennedy 0 m³.</a:t>
             </a:r>
           </a:p>
           <a:p>
@@ -3735,7 +3736,7 @@
       </p:sp>
       <p:pic>
         <p:nvPicPr>
-          <p:cNvPr id="10" name="Picture 9" descr="mensual_MAM.png"/>
+          <p:cNvPr id="10" name="Picture 9" descr="mensual_PAK.png"/>
           <p:cNvPicPr>
             <a:picLocks noChangeAspect="1"/>
           </p:cNvPicPr>
@@ -3750,7 +3751,7 @@
         <p:spPr>
           <a:xfrm>
             <a:off x="256032" y="2542032"/>
-            <a:ext cx="5806440" cy="2385316"/>
+            <a:ext cx="5806440" cy="2391235"/>
           </a:xfrm>
           <a:prstGeom prst="rect">
             <a:avLst/>
@@ -3862,7 +3863,7 @@
                 </a:solidFill>
                 <a:latin typeface="Calibri"/>
               </a:rPr>
-              <a:t>Matriz Andén</a:t>
+              <a:t>Andén 3-4 Matriz</a:t>
             </a:r>
           </a:p>
         </p:txBody>
@@ -3901,7 +3902,7 @@
                 </a:solidFill>
                 <a:latin typeface="Calibri"/>
               </a:rPr>
-              <a:t>0 m³</a:t>
+              <a:t>706 m³</a:t>
             </a:r>
           </a:p>
         </p:txBody>
@@ -5708,7 +5709,7 @@
                 </a:solidFill>
                 <a:latin typeface="Calibri"/>
               </a:rPr>
-              <a:t>YA OPERATIVO  ·  control nocturno</a:t>
+              <a:t>YA OPERATIVO  ·  control WES</a:t>
             </a:r>
           </a:p>
         </p:txBody>
@@ -5722,7 +5723,7 @@
         <p:spPr>
           <a:xfrm>
             <a:off x="347472" y="1298448"/>
-            <a:ext cx="5559552" cy="329184"/>
+            <a:ext cx="5559552" cy="384048"/>
           </a:xfrm>
           <a:prstGeom prst="rect">
             <a:avLst/>
@@ -5747,7 +5748,7 @@
                 </a:solidFill>
                 <a:latin typeface="Calibri"/>
               </a:rPr>
-              <a:t>El corte se activa a las 00:30. De 01:00 a 05:00 el consumo quedó en cero.</a:t>
+              <a:t>El corte se activa a las 00:30. De 01:00 a 05:00 el consumo quedó en cero. Estanque Sur no entra: fue mejora de presostato al relocalizar, no un control WES.</a:t>
             </a:r>
           </a:p>
         </p:txBody>
@@ -5760,8 +5761,8 @@
         </p:nvSpPr>
         <p:spPr>
           <a:xfrm>
-            <a:off x="347472" y="1682496"/>
-            <a:ext cx="5541264" cy="1115568"/>
+            <a:off x="347472" y="1755648"/>
+            <a:ext cx="5541264" cy="1353312"/>
           </a:xfrm>
           <a:prstGeom prst="roundRect">
             <a:avLst>
@@ -5807,27 +5808,27 @@
         </p:nvSpPr>
         <p:spPr>
           <a:xfrm>
-            <a:off x="457200" y="1737360"/>
-            <a:ext cx="5321808" cy="219456"/>
-          </a:xfrm>
-          <a:prstGeom prst="rect">
-            <a:avLst/>
-          </a:prstGeom>
-          <a:noFill/>
-        </p:spPr>
-        <p:txBody>
-          <a:bodyPr wrap="square">
-            <a:spAutoFit/>
-          </a:bodyPr>
-          <a:lstStyle/>
-          <a:p>
-            <a:pPr algn="l">
-              <a:spcAft>
-                <a:spcPts val="300"/>
-              </a:spcAft>
-            </a:pPr>
-            <a:r>
-              <a:rPr sz="1200" b="1">
+            <a:off x="457200" y="1828800"/>
+            <a:ext cx="5321808" cy="237744"/>
+          </a:xfrm>
+          <a:prstGeom prst="rect">
+            <a:avLst/>
+          </a:prstGeom>
+          <a:noFill/>
+        </p:spPr>
+        <p:txBody>
+          <a:bodyPr wrap="square">
+            <a:spAutoFit/>
+          </a:bodyPr>
+          <a:lstStyle/>
+          <a:p>
+            <a:pPr algn="l">
+              <a:spcAft>
+                <a:spcPts val="300"/>
+              </a:spcAft>
+            </a:pPr>
+            <a:r>
+              <a:rPr sz="1300" b="1">
                 <a:solidFill>
                   <a:srgbClr val="0D3B66"/>
                 </a:solidFill>
@@ -5846,27 +5847,27 @@
         </p:nvSpPr>
         <p:spPr>
           <a:xfrm>
-            <a:off x="457200" y="1975104"/>
-            <a:ext cx="5321808" cy="749808"/>
-          </a:xfrm>
-          <a:prstGeom prst="rect">
-            <a:avLst/>
-          </a:prstGeom>
-          <a:noFill/>
-        </p:spPr>
-        <p:txBody>
-          <a:bodyPr wrap="square">
-            <a:spAutoFit/>
-          </a:bodyPr>
-          <a:lstStyle/>
-          <a:p>
-            <a:pPr algn="l">
-              <a:spcAft>
-                <a:spcPts val="300"/>
-              </a:spcAft>
-            </a:pPr>
-            <a:r>
-              <a:rPr sz="1100" b="0">
+            <a:off x="457200" y="2121408"/>
+            <a:ext cx="5321808" cy="877824"/>
+          </a:xfrm>
+          <a:prstGeom prst="rect">
+            <a:avLst/>
+          </a:prstGeom>
+          <a:noFill/>
+        </p:spPr>
+        <p:txBody>
+          <a:bodyPr wrap="square">
+            <a:spAutoFit/>
+          </a:bodyPr>
+          <a:lstStyle/>
+          <a:p>
+            <a:pPr algn="l">
+              <a:spcAft>
+                <a:spcPts val="300"/>
+              </a:spcAft>
+            </a:pPr>
+            <a:r>
+              <a:rPr sz="1200" b="0">
                 <a:solidFill>
                   <a:srgbClr val="0D3B66"/>
                 </a:solidFill>
@@ -5885,8 +5886,8 @@
         </p:nvSpPr>
         <p:spPr>
           <a:xfrm>
-            <a:off x="347472" y="2871216"/>
-            <a:ext cx="5541264" cy="1115568"/>
+            <a:off x="347472" y="3218688"/>
+            <a:ext cx="5541264" cy="1353312"/>
           </a:xfrm>
           <a:prstGeom prst="roundRect">
             <a:avLst>
@@ -5932,27 +5933,27 @@
         </p:nvSpPr>
         <p:spPr>
           <a:xfrm>
-            <a:off x="457200" y="2926080"/>
-            <a:ext cx="5321808" cy="219456"/>
-          </a:xfrm>
-          <a:prstGeom prst="rect">
-            <a:avLst/>
-          </a:prstGeom>
-          <a:noFill/>
-        </p:spPr>
-        <p:txBody>
-          <a:bodyPr wrap="square">
-            <a:spAutoFit/>
-          </a:bodyPr>
-          <a:lstStyle/>
-          <a:p>
-            <a:pPr algn="l">
-              <a:spcAft>
-                <a:spcPts val="300"/>
-              </a:spcAft>
-            </a:pPr>
-            <a:r>
-              <a:rPr sz="1200" b="1">
+            <a:off x="457200" y="3291840"/>
+            <a:ext cx="5321808" cy="237744"/>
+          </a:xfrm>
+          <a:prstGeom prst="rect">
+            <a:avLst/>
+          </a:prstGeom>
+          <a:noFill/>
+        </p:spPr>
+        <p:txBody>
+          <a:bodyPr wrap="square">
+            <a:spAutoFit/>
+          </a:bodyPr>
+          <a:lstStyle/>
+          <a:p>
+            <a:pPr algn="l">
+              <a:spcAft>
+                <a:spcPts val="300"/>
+              </a:spcAft>
+            </a:pPr>
+            <a:r>
+              <a:rPr sz="1300" b="1">
                 <a:solidFill>
                   <a:srgbClr val="0D3B66"/>
                 </a:solidFill>
@@ -5971,27 +5972,27 @@
         </p:nvSpPr>
         <p:spPr>
           <a:xfrm>
-            <a:off x="457200" y="3163824"/>
-            <a:ext cx="5321808" cy="749808"/>
-          </a:xfrm>
-          <a:prstGeom prst="rect">
-            <a:avLst/>
-          </a:prstGeom>
-          <a:noFill/>
-        </p:spPr>
-        <p:txBody>
-          <a:bodyPr wrap="square">
-            <a:spAutoFit/>
-          </a:bodyPr>
-          <a:lstStyle/>
-          <a:p>
-            <a:pPr algn="l">
-              <a:spcAft>
-                <a:spcPts val="300"/>
-              </a:spcAft>
-            </a:pPr>
-            <a:r>
-              <a:rPr sz="1100" b="0">
+            <a:off x="457200" y="3584448"/>
+            <a:ext cx="5321808" cy="877824"/>
+          </a:xfrm>
+          <a:prstGeom prst="rect">
+            <a:avLst/>
+          </a:prstGeom>
+          <a:noFill/>
+        </p:spPr>
+        <p:txBody>
+          <a:bodyPr wrap="square">
+            <a:spAutoFit/>
+          </a:bodyPr>
+          <a:lstStyle/>
+          <a:p>
+            <a:pPr algn="l">
+              <a:spcAft>
+                <a:spcPts val="300"/>
+              </a:spcAft>
+            </a:pPr>
+            <a:r>
+              <a:rPr sz="1200" b="0">
                 <a:solidFill>
                   <a:srgbClr val="0D3B66"/>
                 </a:solidFill>
@@ -6010,8 +6011,8 @@
         </p:nvSpPr>
         <p:spPr>
           <a:xfrm>
-            <a:off x="347472" y="4059936"/>
-            <a:ext cx="5541264" cy="1115568"/>
+            <a:off x="347472" y="4681728"/>
+            <a:ext cx="5541264" cy="1353312"/>
           </a:xfrm>
           <a:prstGeom prst="roundRect">
             <a:avLst>
@@ -6057,27 +6058,27 @@
         </p:nvSpPr>
         <p:spPr>
           <a:xfrm>
-            <a:off x="457200" y="4114800"/>
-            <a:ext cx="5321808" cy="219456"/>
-          </a:xfrm>
-          <a:prstGeom prst="rect">
-            <a:avLst/>
-          </a:prstGeom>
-          <a:noFill/>
-        </p:spPr>
-        <p:txBody>
-          <a:bodyPr wrap="square">
-            <a:spAutoFit/>
-          </a:bodyPr>
-          <a:lstStyle/>
-          <a:p>
-            <a:pPr algn="l">
-              <a:spcAft>
-                <a:spcPts val="300"/>
-              </a:spcAft>
-            </a:pPr>
-            <a:r>
-              <a:rPr sz="1200" b="1">
+            <a:off x="457200" y="4754880"/>
+            <a:ext cx="5321808" cy="237744"/>
+          </a:xfrm>
+          <a:prstGeom prst="rect">
+            <a:avLst/>
+          </a:prstGeom>
+          <a:noFill/>
+        </p:spPr>
+        <p:txBody>
+          <a:bodyPr wrap="square">
+            <a:spAutoFit/>
+          </a:bodyPr>
+          <a:lstStyle/>
+          <a:p>
+            <a:pPr algn="l">
+              <a:spcAft>
+                <a:spcPts val="300"/>
+              </a:spcAft>
+            </a:pPr>
+            <a:r>
+              <a:rPr sz="1300" b="1">
                 <a:solidFill>
                   <a:srgbClr val="0D3B66"/>
                 </a:solidFill>
@@ -6096,27 +6097,27 @@
         </p:nvSpPr>
         <p:spPr>
           <a:xfrm>
-            <a:off x="457200" y="4352544"/>
-            <a:ext cx="5321808" cy="749808"/>
-          </a:xfrm>
-          <a:prstGeom prst="rect">
-            <a:avLst/>
-          </a:prstGeom>
-          <a:noFill/>
-        </p:spPr>
-        <p:txBody>
-          <a:bodyPr wrap="square">
-            <a:spAutoFit/>
-          </a:bodyPr>
-          <a:lstStyle/>
-          <a:p>
-            <a:pPr algn="l">
-              <a:spcAft>
-                <a:spcPts val="300"/>
-              </a:spcAft>
-            </a:pPr>
-            <a:r>
-              <a:rPr sz="1100" b="0">
+            <a:off x="457200" y="5047488"/>
+            <a:ext cx="5321808" cy="877824"/>
+          </a:xfrm>
+          <a:prstGeom prst="rect">
+            <a:avLst/>
+          </a:prstGeom>
+          <a:noFill/>
+        </p:spPr>
+        <p:txBody>
+          <a:bodyPr wrap="square">
+            <a:spAutoFit/>
+          </a:bodyPr>
+          <a:lstStyle/>
+          <a:p>
+            <a:pPr algn="l">
+              <a:spcAft>
+                <a:spcPts val="300"/>
+              </a:spcAft>
+            </a:pPr>
+            <a:r>
+              <a:rPr sz="1200" b="0">
                 <a:solidFill>
                   <a:srgbClr val="0D3B66"/>
                 </a:solidFill>
@@ -6129,132 +6130,7 @@
       </p:sp>
       <p:sp>
         <p:nvSpPr>
-          <p:cNvPr id="19" name="Rounded Rectangle 18"/>
-          <p:cNvSpPr/>
-          <p:nvPr/>
-        </p:nvSpPr>
-        <p:spPr>
-          <a:xfrm>
-            <a:off x="347472" y="5248656"/>
-            <a:ext cx="5541264" cy="1115568"/>
-          </a:xfrm>
-          <a:prstGeom prst="roundRect">
-            <a:avLst>
-              <a:gd name="adj" fmla="val 8000"/>
-            </a:avLst>
-          </a:prstGeom>
-          <a:solidFill>
-            <a:srgbClr val="FFFFFF"/>
-          </a:solidFill>
-          <a:ln w="6350">
-            <a:solidFill>
-              <a:srgbClr val="1F77B4"/>
-            </a:solidFill>
-          </a:ln>
-        </p:spPr>
-        <p:style>
-          <a:lnRef idx="1">
-            <a:schemeClr val="accent1"/>
-          </a:lnRef>
-          <a:fillRef idx="3">
-            <a:schemeClr val="accent1"/>
-          </a:fillRef>
-          <a:effectRef idx="2">
-            <a:schemeClr val="accent1"/>
-          </a:effectRef>
-          <a:fontRef idx="minor">
-            <a:schemeClr val="lt1"/>
-          </a:fontRef>
-        </p:style>
-        <p:txBody>
-          <a:bodyPr rtlCol="0" anchor="ctr"/>
-          <a:lstStyle/>
-          <a:p>
-            <a:pPr algn="ctr"/>
-          </a:p>
-        </p:txBody>
-      </p:sp>
-      <p:sp>
-        <p:nvSpPr>
-          <p:cNvPr id="20" name="TextBox 19"/>
-          <p:cNvSpPr txBox="1"/>
-          <p:nvPr/>
-        </p:nvSpPr>
-        <p:spPr>
-          <a:xfrm>
-            <a:off x="457200" y="5303520"/>
-            <a:ext cx="5321808" cy="219456"/>
-          </a:xfrm>
-          <a:prstGeom prst="rect">
-            <a:avLst/>
-          </a:prstGeom>
-          <a:noFill/>
-        </p:spPr>
-        <p:txBody>
-          <a:bodyPr wrap="square">
-            <a:spAutoFit/>
-          </a:bodyPr>
-          <a:lstStyle/>
-          <a:p>
-            <a:pPr algn="l">
-              <a:spcAft>
-                <a:spcPts val="300"/>
-              </a:spcAft>
-            </a:pPr>
-            <a:r>
-              <a:rPr sz="1200" b="1">
-                <a:solidFill>
-                  <a:srgbClr val="0D3B66"/>
-                </a:solidFill>
-                <a:latin typeface="Calibri"/>
-              </a:rPr>
-              <a:t>MAE  ·  Estanque Sur</a:t>
-            </a:r>
-          </a:p>
-        </p:txBody>
-      </p:sp>
-      <p:sp>
-        <p:nvSpPr>
-          <p:cNvPr id="21" name="TextBox 20"/>
-          <p:cNvSpPr txBox="1"/>
-          <p:nvPr/>
-        </p:nvSpPr>
-        <p:spPr>
-          <a:xfrm>
-            <a:off x="457200" y="5541264"/>
-            <a:ext cx="5321808" cy="749808"/>
-          </a:xfrm>
-          <a:prstGeom prst="rect">
-            <a:avLst/>
-          </a:prstGeom>
-          <a:noFill/>
-        </p:spPr>
-        <p:txBody>
-          <a:bodyPr wrap="square">
-            <a:spAutoFit/>
-          </a:bodyPr>
-          <a:lstStyle/>
-          <a:p>
-            <a:pPr algn="l">
-              <a:spcAft>
-                <a:spcPts val="300"/>
-              </a:spcAft>
-            </a:pPr>
-            <a:r>
-              <a:rPr sz="1100" b="0">
-                <a:solidFill>
-                  <a:srgbClr val="0D3B66"/>
-                </a:solidFill>
-                <a:latin typeface="Calibri"/>
-              </a:rPr>
-              <a:t>No es on/off: presostatos 10/06. Día 88 → 28 m³. 1.826 m³/mes ($2.555.700). El mayor ahorro ya logrado.</a:t>
-            </a:r>
-          </a:p>
-        </p:txBody>
-      </p:sp>
-      <p:sp>
-        <p:nvSpPr>
-          <p:cNvPr id="22" name="TextBox 21"/>
+          <p:cNvPr id="19" name="TextBox 18"/>
           <p:cNvSpPr txBox="1"/>
           <p:nvPr/>
         </p:nvSpPr>
@@ -6286,14 +6162,14 @@
                 </a:solidFill>
                 <a:latin typeface="Calibri"/>
               </a:rPr>
-              <a:t>Total logrado MAE + BOM: 2.825 m³/mes  ·  $3.954.720</a:t>
-            </a:r>
-          </a:p>
-        </p:txBody>
-      </p:sp>
-      <p:sp>
-        <p:nvSpPr>
-          <p:cNvPr id="23" name="Rounded Rectangle 22"/>
+              <a:t>Total control WES: 999 m³/mes  ·  $1.399.020</a:t>
+            </a:r>
+          </a:p>
+        </p:txBody>
+      </p:sp>
+      <p:sp>
+        <p:nvSpPr>
+          <p:cNvPr id="20" name="Rounded Rectangle 19"/>
           <p:cNvSpPr/>
           <p:nvPr/>
         </p:nvSpPr>
@@ -6340,7 +6216,7 @@
       </p:sp>
       <p:sp>
         <p:nvSpPr>
-          <p:cNvPr id="24" name="TextBox 23"/>
+          <p:cNvPr id="21" name="TextBox 20"/>
           <p:cNvSpPr txBox="1"/>
           <p:nvPr/>
         </p:nvSpPr>
@@ -6379,7 +6255,7 @@
       </p:sp>
       <p:sp>
         <p:nvSpPr>
-          <p:cNvPr id="25" name="TextBox 24"/>
+          <p:cNvPr id="22" name="TextBox 21"/>
           <p:cNvSpPr txBox="1"/>
           <p:nvPr/>
         </p:nvSpPr>
@@ -6418,7 +6294,7 @@
       </p:sp>
       <p:sp>
         <p:nvSpPr>
-          <p:cNvPr id="26" name="Rounded Rectangle 25"/>
+          <p:cNvPr id="23" name="Rounded Rectangle 22"/>
           <p:cNvSpPr/>
           <p:nvPr/>
         </p:nvSpPr>
@@ -6465,7 +6341,7 @@
       </p:sp>
       <p:sp>
         <p:nvSpPr>
-          <p:cNvPr id="27" name="TextBox 26"/>
+          <p:cNvPr id="24" name="TextBox 23"/>
           <p:cNvSpPr txBox="1"/>
           <p:nvPr/>
         </p:nvSpPr>
@@ -6504,7 +6380,7 @@
       </p:sp>
       <p:sp>
         <p:nvSpPr>
-          <p:cNvPr id="28" name="TextBox 27"/>
+          <p:cNvPr id="25" name="TextBox 24"/>
           <p:cNvSpPr txBox="1"/>
           <p:nvPr/>
         </p:nvSpPr>
@@ -6543,7 +6419,7 @@
       </p:sp>
       <p:sp>
         <p:nvSpPr>
-          <p:cNvPr id="29" name="Rounded Rectangle 28"/>
+          <p:cNvPr id="26" name="Rounded Rectangle 25"/>
           <p:cNvSpPr/>
           <p:nvPr/>
         </p:nvSpPr>
@@ -6590,7 +6466,7 @@
       </p:sp>
       <p:sp>
         <p:nvSpPr>
-          <p:cNvPr id="30" name="TextBox 29"/>
+          <p:cNvPr id="27" name="TextBox 26"/>
           <p:cNvSpPr txBox="1"/>
           <p:nvPr/>
         </p:nvSpPr>
@@ -6629,7 +6505,7 @@
       </p:sp>
       <p:sp>
         <p:nvSpPr>
-          <p:cNvPr id="31" name="TextBox 30"/>
+          <p:cNvPr id="28" name="TextBox 27"/>
           <p:cNvSpPr txBox="1"/>
           <p:nvPr/>
         </p:nvSpPr>
@@ -6661,14 +6537,14 @@
                 </a:solidFill>
                 <a:latin typeface="Calibri"/>
               </a:rPr>
-              <a:t>On/off 00:30 (no las Sandías). Noche 29,1 m³ → 0 = 874 m³/mes ($1.224.300). Umbral 24 h: 250 m³/día.</a:t>
-            </a:r>
-          </a:p>
-        </p:txBody>
-      </p:sp>
-      <p:sp>
-        <p:nvSpPr>
-          <p:cNvPr id="32" name="Rounded Rectangle 31"/>
+              <a:t>On/off 00:30 (no las Sandías). Noche 29,1 m³ → 0 = 874 m³/mes ($1.224.300). Umbral 250 m³/día.</a:t>
+            </a:r>
+          </a:p>
+        </p:txBody>
+      </p:sp>
+      <p:sp>
+        <p:nvSpPr>
+          <p:cNvPr id="29" name="Rounded Rectangle 28"/>
           <p:cNvSpPr/>
           <p:nvPr/>
         </p:nvSpPr>
@@ -6715,7 +6591,7 @@
       </p:sp>
       <p:sp>
         <p:nvSpPr>
-          <p:cNvPr id="33" name="TextBox 32"/>
+          <p:cNvPr id="30" name="TextBox 29"/>
           <p:cNvSpPr txBox="1"/>
           <p:nvPr/>
         </p:nvSpPr>
@@ -6747,14 +6623,14 @@
                 </a:solidFill>
                 <a:latin typeface="Calibri"/>
               </a:rPr>
-              <a:t>PAK  ·  DL Kennedy</a:t>
-            </a:r>
-          </a:p>
-        </p:txBody>
-      </p:sp>
-      <p:sp>
-        <p:nvSpPr>
-          <p:cNvPr id="34" name="TextBox 33"/>
+              <a:t>PAK  ·  Andén 3-4 Matriz</a:t>
+            </a:r>
+          </a:p>
+        </p:txBody>
+      </p:sp>
+      <p:sp>
+        <p:nvSpPr>
+          <p:cNvPr id="31" name="TextBox 30"/>
           <p:cNvSpPr txBox="1"/>
           <p:nvPr/>
         </p:nvSpPr>
@@ -6786,14 +6662,14 @@
                 </a:solidFill>
                 <a:latin typeface="Calibri"/>
               </a:rPr>
-              <a:t>On/off 00:30 (no las Sandías). Noche 0,9 m³ → 0 = 27 m³/mes ($37.800). Umbral 24 h: 20 m³/día.</a:t>
-            </a:r>
-          </a:p>
-        </p:txBody>
-      </p:sp>
-      <p:sp>
-        <p:nvSpPr>
-          <p:cNvPr id="35" name="Rounded Rectangle 34"/>
+              <a:t>On/off 00:30 en la matriz del Andén (no DL Kennedy). Noche 6 m³ → 0 = 178 m³/mes ($249.900). Umbral 125 m³/día.</a:t>
+            </a:r>
+          </a:p>
+        </p:txBody>
+      </p:sp>
+      <p:sp>
+        <p:nvSpPr>
+          <p:cNvPr id="32" name="Rounded Rectangle 31"/>
           <p:cNvSpPr/>
           <p:nvPr/>
         </p:nvSpPr>
@@ -6840,7 +6716,7 @@
       </p:sp>
       <p:sp>
         <p:nvSpPr>
-          <p:cNvPr id="36" name="TextBox 35"/>
+          <p:cNvPr id="33" name="TextBox 32"/>
           <p:cNvSpPr txBox="1"/>
           <p:nvPr/>
         </p:nvSpPr>
@@ -6879,7 +6755,7 @@
       </p:sp>
       <p:sp>
         <p:nvSpPr>
-          <p:cNvPr id="37" name="TextBox 36"/>
+          <p:cNvPr id="34" name="TextBox 33"/>
           <p:cNvSpPr txBox="1"/>
           <p:nvPr/>
         </p:nvSpPr>
@@ -6911,14 +6787,14 @@
                 </a:solidFill>
                 <a:latin typeface="Calibri"/>
               </a:rPr>
-              <a:t>On/off 00:30 en el primer piso (no Anillo). Noche 6,8 m³ → 0 = 205 m³/mes ($286.860). Umbral 24 h: 75 m³/día.</a:t>
-            </a:r>
-          </a:p>
-        </p:txBody>
-      </p:sp>
-      <p:sp>
-        <p:nvSpPr>
-          <p:cNvPr id="38" name="Rounded Rectangle 37"/>
+              <a:t>On/off 00:30 en el primer piso (no Anillo). Noche 6,8 m³ → 0 = 205 m³/mes ($286.860). Umbral 75 m³/día.</a:t>
+            </a:r>
+          </a:p>
+        </p:txBody>
+      </p:sp>
+      <p:sp>
+        <p:nvSpPr>
+          <p:cNvPr id="35" name="Rounded Rectangle 34"/>
           <p:cNvSpPr/>
           <p:nvPr/>
         </p:nvSpPr>
@@ -6965,7 +6841,7 @@
       </p:sp>
       <p:sp>
         <p:nvSpPr>
-          <p:cNvPr id="39" name="TextBox 38"/>
+          <p:cNvPr id="36" name="TextBox 35"/>
           <p:cNvSpPr txBox="1"/>
           <p:nvPr/>
         </p:nvSpPr>
@@ -7004,7 +6880,7 @@
       </p:sp>
       <p:sp>
         <p:nvSpPr>
-          <p:cNvPr id="40" name="TextBox 39"/>
+          <p:cNvPr id="37" name="TextBox 36"/>
           <p:cNvSpPr txBox="1"/>
           <p:nvPr/>
         </p:nvSpPr>
@@ -7043,7 +6919,7 @@
       </p:sp>
       <p:sp>
         <p:nvSpPr>
-          <p:cNvPr id="41" name="TextBox 40"/>
+          <p:cNvPr id="38" name="TextBox 37"/>
           <p:cNvSpPr txBox="1"/>
           <p:nvPr/>
         </p:nvSpPr>
@@ -7075,7 +6951,315 @@
                 </a:solidFill>
                 <a:latin typeface="Calibri"/>
               </a:rPr>
-              <a:t>Si se aprueban las 5: 4.814 m³/mes  ·  $6.739.390</a:t>
+              <a:t>Si se aprueban las 5: 3.139 m³/mes  ·  $4.395.090</a:t>
+            </a:r>
+          </a:p>
+        </p:txBody>
+      </p:sp>
+    </p:spTree>
+  </p:cSld>
+  <p:clrMapOvr>
+    <a:masterClrMapping/>
+  </p:clrMapOvr>
+</p:sld>
+</file>
+
+<file path=ppt/slides/slide12.xml><?xml version="1.0" encoding="utf-8"?>
+<p:sld xmlns:a="http://schemas.openxmlformats.org/drawingml/2006/main" xmlns:p="http://schemas.openxmlformats.org/presentationml/2006/main" xmlns:r="http://schemas.openxmlformats.org/officeDocument/2006/relationships">
+  <p:cSld>
+    <p:spTree>
+      <p:nvGrpSpPr>
+        <p:cNvPr id="1" name=""/>
+        <p:cNvGrpSpPr/>
+        <p:nvPr/>
+      </p:nvGrpSpPr>
+      <p:grpSpPr/>
+      <p:sp>
+        <p:nvSpPr>
+          <p:cNvPr id="2" name="Rectangle 1"/>
+          <p:cNvSpPr/>
+          <p:nvPr/>
+        </p:nvSpPr>
+        <p:spPr>
+          <a:xfrm>
+            <a:off x="0" y="0"/>
+            <a:ext cx="12191695" cy="841248"/>
+          </a:xfrm>
+          <a:prstGeom prst="rect">
+            <a:avLst/>
+          </a:prstGeom>
+          <a:solidFill>
+            <a:srgbClr val="0D3B66"/>
+          </a:solidFill>
+          <a:ln>
+            <a:noFill/>
+          </a:ln>
+        </p:spPr>
+        <p:style>
+          <a:lnRef idx="1">
+            <a:schemeClr val="accent1"/>
+          </a:lnRef>
+          <a:fillRef idx="3">
+            <a:schemeClr val="accent1"/>
+          </a:fillRef>
+          <a:effectRef idx="2">
+            <a:schemeClr val="accent1"/>
+          </a:effectRef>
+          <a:fontRef idx="minor">
+            <a:schemeClr val="lt1"/>
+          </a:fontRef>
+        </p:style>
+        <p:txBody>
+          <a:bodyPr rtlCol="0" anchor="ctr"/>
+          <a:lstStyle/>
+          <a:p>
+            <a:pPr algn="ctr"/>
+          </a:p>
+        </p:txBody>
+      </p:sp>
+      <p:sp>
+        <p:nvSpPr>
+          <p:cNvPr id="3" name="Rectangle 2"/>
+          <p:cNvSpPr/>
+          <p:nvPr/>
+        </p:nvSpPr>
+        <p:spPr>
+          <a:xfrm>
+            <a:off x="0" y="841248"/>
+            <a:ext cx="12191695" cy="54864"/>
+          </a:xfrm>
+          <a:prstGeom prst="rect">
+            <a:avLst/>
+          </a:prstGeom>
+          <a:solidFill>
+            <a:srgbClr val="C9A227"/>
+          </a:solidFill>
+          <a:ln>
+            <a:noFill/>
+          </a:ln>
+        </p:spPr>
+        <p:style>
+          <a:lnRef idx="1">
+            <a:schemeClr val="accent1"/>
+          </a:lnRef>
+          <a:fillRef idx="3">
+            <a:schemeClr val="accent1"/>
+          </a:fillRef>
+          <a:effectRef idx="2">
+            <a:schemeClr val="accent1"/>
+          </a:effectRef>
+          <a:fontRef idx="minor">
+            <a:schemeClr val="lt1"/>
+          </a:fontRef>
+        </p:style>
+        <p:txBody>
+          <a:bodyPr rtlCol="0" anchor="ctr"/>
+          <a:lstStyle/>
+          <a:p>
+            <a:pPr algn="ctr"/>
+          </a:p>
+        </p:txBody>
+      </p:sp>
+      <p:pic>
+        <p:nvPicPr>
+          <p:cNvPr id="4" name="Picture 3" descr="logo wes.bmp"/>
+          <p:cNvPicPr>
+            <a:picLocks noChangeAspect="1"/>
+          </p:cNvPicPr>
+          <p:nvPr/>
+        </p:nvPicPr>
+        <p:blipFill>
+          <a:blip r:embed="rId2"/>
+          <a:stretch>
+            <a:fillRect/>
+          </a:stretch>
+        </p:blipFill>
+        <p:spPr>
+          <a:xfrm>
+            <a:off x="10835640" y="146304"/>
+            <a:ext cx="1143000" cy="253401"/>
+          </a:xfrm>
+          <a:prstGeom prst="rect">
+            <a:avLst/>
+          </a:prstGeom>
+        </p:spPr>
+      </p:pic>
+      <p:sp>
+        <p:nvSpPr>
+          <p:cNvPr id="5" name="TextBox 4"/>
+          <p:cNvSpPr txBox="1"/>
+          <p:nvPr/>
+        </p:nvSpPr>
+        <p:spPr>
+          <a:xfrm>
+            <a:off x="256032" y="109728"/>
+            <a:ext cx="10607040" cy="384048"/>
+          </a:xfrm>
+          <a:prstGeom prst="rect">
+            <a:avLst/>
+          </a:prstGeom>
+          <a:noFill/>
+        </p:spPr>
+        <p:txBody>
+          <a:bodyPr wrap="square">
+            <a:spAutoFit/>
+          </a:bodyPr>
+          <a:lstStyle/>
+          <a:p>
+            <a:pPr algn="l">
+              <a:spcAft>
+                <a:spcPts val="300"/>
+              </a:spcAft>
+            </a:pPr>
+            <a:r>
+              <a:rPr sz="2000" b="1">
+                <a:solidFill>
+                  <a:srgbClr val="FFFFFF"/>
+                </a:solidFill>
+                <a:latin typeface="Calibri"/>
+              </a:rPr>
+              <a:t>Futuros puntos de control</a:t>
+            </a:r>
+          </a:p>
+        </p:txBody>
+      </p:sp>
+      <p:sp>
+        <p:nvSpPr>
+          <p:cNvPr id="6" name="TextBox 5"/>
+          <p:cNvSpPr txBox="1"/>
+          <p:nvPr/>
+        </p:nvSpPr>
+        <p:spPr>
+          <a:xfrm>
+            <a:off x="256032" y="457200"/>
+            <a:ext cx="10607040" cy="329184"/>
+          </a:xfrm>
+          <a:prstGeom prst="rect">
+            <a:avLst/>
+          </a:prstGeom>
+          <a:noFill/>
+        </p:spPr>
+        <p:txBody>
+          <a:bodyPr wrap="square">
+            <a:spAutoFit/>
+          </a:bodyPr>
+          <a:lstStyle/>
+          <a:p>
+            <a:pPr algn="l">
+              <a:spcAft>
+                <a:spcPts val="300"/>
+              </a:spcAft>
+            </a:pPr>
+            <a:r>
+              <a:rPr sz="1100" b="0">
+                <a:solidFill>
+                  <a:srgbClr val="DCE6F0"/>
+                </a:solidFill>
+                <a:latin typeface="Calibri"/>
+              </a:rPr>
+              <a:t>Mismo corte 00:30 → cero  ·  tarifa $1.400/m³  ·  08/09/2026</a:t>
+            </a:r>
+          </a:p>
+        </p:txBody>
+      </p:sp>
+      <p:sp>
+        <p:nvSpPr>
+          <p:cNvPr id="7" name="TextBox 6"/>
+          <p:cNvSpPr txBox="1"/>
+          <p:nvPr/>
+        </p:nvSpPr>
+        <p:spPr>
+          <a:xfrm>
+            <a:off x="256032" y="1024128"/>
+            <a:ext cx="11612880" cy="329184"/>
+          </a:xfrm>
+          <a:prstGeom prst="rect">
+            <a:avLst/>
+          </a:prstGeom>
+          <a:noFill/>
+        </p:spPr>
+        <p:txBody>
+          <a:bodyPr wrap="square">
+            <a:spAutoFit/>
+          </a:bodyPr>
+          <a:lstStyle/>
+          <a:p>
+            <a:pPr algn="l">
+              <a:spcAft>
+                <a:spcPts val="300"/>
+              </a:spcAft>
+            </a:pPr>
+            <a:r>
+              <a:rPr sz="1300" b="0">
+                <a:solidFill>
+                  <a:srgbClr val="0D3B66"/>
+                </a:solidFill>
+                <a:latin typeface="Calibri"/>
+              </a:rPr>
+              <a:t>Cinco on/off a copiar del que ya corre en Estanque Norte y San Ignacio 500. No incluye Estanque Sur (no es control WES) ni DL Kennedy.</a:t>
+            </a:r>
+          </a:p>
+        </p:txBody>
+      </p:sp>
+      <p:pic>
+        <p:nvPicPr>
+          <p:cNvPr id="8" name="Picture 7" descr="futuros_puntos_control.png"/>
+          <p:cNvPicPr>
+            <a:picLocks noChangeAspect="1"/>
+          </p:cNvPicPr>
+          <p:nvPr/>
+        </p:nvPicPr>
+        <p:blipFill>
+          <a:blip r:embed="rId3"/>
+          <a:stretch>
+            <a:fillRect/>
+          </a:stretch>
+        </p:blipFill>
+        <p:spPr>
+          <a:xfrm>
+            <a:off x="320040" y="1417320"/>
+            <a:ext cx="11521440" cy="4659782"/>
+          </a:xfrm>
+          <a:prstGeom prst="rect">
+            <a:avLst/>
+          </a:prstGeom>
+        </p:spPr>
+      </p:pic>
+      <p:sp>
+        <p:nvSpPr>
+          <p:cNvPr id="9" name="TextBox 8"/>
+          <p:cNvSpPr txBox="1"/>
+          <p:nvPr/>
+        </p:nvSpPr>
+        <p:spPr>
+          <a:xfrm>
+            <a:off x="256032" y="6446520"/>
+            <a:ext cx="11612880" cy="201168"/>
+          </a:xfrm>
+          <a:prstGeom prst="rect">
+            <a:avLst/>
+          </a:prstGeom>
+          <a:noFill/>
+        </p:spPr>
+        <p:txBody>
+          <a:bodyPr wrap="square">
+            <a:spAutoFit/>
+          </a:bodyPr>
+          <a:lstStyle/>
+          <a:p>
+            <a:pPr algn="ctr">
+              <a:spcAft>
+                <a:spcPts val="300"/>
+              </a:spcAft>
+            </a:pPr>
+            <a:r>
+              <a:rPr sz="1400" b="1">
+                <a:solidFill>
+                  <a:srgbClr val="0D3B66"/>
+                </a:solidFill>
+                <a:latin typeface="Calibri"/>
+              </a:rPr>
+              <a:t>Suma de las 5: 2.140 m³/mes  ·  $2.996.490</a:t>
             </a:r>
           </a:p>
         </p:txBody>
@@ -12339,7 +12523,7 @@
                 </a:solidFill>
                 <a:latin typeface="Calibri"/>
               </a:rPr>
-              <a:t>0</a:t>
+              <a:t>3.094</a:t>
             </a:r>
           </a:p>
         </p:txBody>
@@ -12425,7 +12609,7 @@
                 </a:solidFill>
                 <a:latin typeface="Calibri"/>
               </a:rPr>
-              <a:t>0</a:t>
+              <a:t>797</a:t>
             </a:r>
           </a:p>
         </p:txBody>
@@ -12511,7 +12695,7 @@
                 </a:solidFill>
                 <a:latin typeface="Calibri"/>
               </a:rPr>
-              <a:t>0</a:t>
+              <a:t>718</a:t>
             </a:r>
           </a:p>
         </p:txBody>
@@ -12597,7 +12781,7 @@
                 </a:solidFill>
                 <a:latin typeface="Calibri"/>
               </a:rPr>
-              <a:t>0</a:t>
+              <a:t>706</a:t>
             </a:r>
           </a:p>
         </p:txBody>
@@ -12683,7 +12867,7 @@
                 </a:solidFill>
                 <a:latin typeface="Calibri"/>
               </a:rPr>
-              <a:t>n/d</a:t>
+              <a:t>↓ 2 %</a:t>
             </a:r>
           </a:p>
         </p:txBody>
@@ -12769,7 +12953,7 @@
                 </a:solidFill>
                 <a:latin typeface="Calibri"/>
               </a:rPr>
-              <a:t>Matriz Andén  0</a:t>
+              <a:t>Andén 3-4 Matriz  706</a:t>
             </a:r>
           </a:p>
         </p:txBody>
@@ -13328,7 +13512,7 @@
                 </a:solidFill>
                 <a:latin typeface="Calibri"/>
               </a:rPr>
-              <a:t>•  PAK: Matriz Andén (000025-20), Locales Gast. (000025-21), Sandía Antigua (000025-22), Pileta (000025-23), Cascada (000025-24), Sandía Nueva (000025-28), Restaurante (000025-29)</a:t>
+              <a:t>•  PAK: Locales Gast. (000025-21), Sandía Antigua (000025-22), Pileta (000025-23), Cascada (000025-24), Sandía Nueva (000025-28), Restaurante (000025-29)</a:t>
             </a:r>
           </a:p>
         </p:txBody>
@@ -13610,7 +13794,7 @@
                 </a:solidFill>
                 <a:latin typeface="Calibri"/>
               </a:rPr>
-              <a:t>•  MAE — Estanque Sur: reparación de presostatos 10/06. Pizza Hut con control nocturno desde 01/07. Estanque Norte con control desde 05/08 (00–05 h).</a:t>
+              <a:t>•  MAE — Estanque Norte con control desde 05/08 (00–05 h). Pizza Hut con control nocturno desde 01/07. Estanque Sur: mejora de presostato al relocalizar (10/06); no es control WES.</a:t>
             </a:r>
           </a:p>
           <a:p>

</xml_diff>

<commit_message>
fix(pa): barras verdes de Norte y SI500 de vuelta en la proyección
El gráfico mezcla control WES ya operativo (verde) y las cinco
propuestas (dorado). Estanque Sur sigue fuera.

Co-authored-by: anibaloperacionesWes <anibaloperacionesWes@users.noreply.github.com>
</commit_message>
<xml_diff>
--- a/reports/Parque_Arauco/CONSOLIDADO/Consolidado_PA_7malls_20260908.pptx
+++ b/reports/Parque_Arauco/CONSOLIDADO/Consolidado_PA_7malls_20260908.pptx
@@ -7118,7 +7118,7 @@
                 </a:solidFill>
                 <a:latin typeface="Calibri"/>
               </a:rPr>
-              <a:t>Futuros puntos de control</a:t>
+              <a:t>Proyección: ya operativo y a copiar</a:t>
             </a:r>
           </a:p>
         </p:txBody>
@@ -7157,53 +7157,14 @@
                 </a:solidFill>
                 <a:latin typeface="Calibri"/>
               </a:rPr>
-              <a:t>Mismo corte 00:30 → cero  ·  tarifa $1.400/m³  ·  08/09/2026</a:t>
-            </a:r>
-          </a:p>
-        </p:txBody>
-      </p:sp>
-      <p:sp>
-        <p:nvSpPr>
-          <p:cNvPr id="7" name="TextBox 6"/>
-          <p:cNvSpPr txBox="1"/>
-          <p:nvPr/>
-        </p:nvSpPr>
-        <p:spPr>
-          <a:xfrm>
-            <a:off x="256032" y="1024128"/>
-            <a:ext cx="11612880" cy="329184"/>
-          </a:xfrm>
-          <a:prstGeom prst="rect">
-            <a:avLst/>
-          </a:prstGeom>
-          <a:noFill/>
-        </p:spPr>
-        <p:txBody>
-          <a:bodyPr wrap="square">
-            <a:spAutoFit/>
-          </a:bodyPr>
-          <a:lstStyle/>
-          <a:p>
-            <a:pPr algn="l">
-              <a:spcAft>
-                <a:spcPts val="300"/>
-              </a:spcAft>
-            </a:pPr>
-            <a:r>
-              <a:rPr sz="1300" b="0">
-                <a:solidFill>
-                  <a:srgbClr val="0D3B66"/>
-                </a:solidFill>
-                <a:latin typeface="Calibri"/>
-              </a:rPr>
-              <a:t>Cinco on/off a copiar del que ya corre en Estanque Norte y San Ignacio 500. No incluye Estanque Sur (no es control WES) ni DL Kennedy.</a:t>
+              <a:t>Verde = control WES  ·  dorado = propuesta  ·  tarifa $1.400/m³  ·  08/09/2026</a:t>
             </a:r>
           </a:p>
         </p:txBody>
       </p:sp>
       <p:pic>
         <p:nvPicPr>
-          <p:cNvPr id="8" name="Picture 7" descr="futuros_puntos_control.png"/>
+          <p:cNvPr id="7" name="Picture 6" descr="futuros_puntos_control.png"/>
           <p:cNvPicPr>
             <a:picLocks noChangeAspect="1"/>
           </p:cNvPicPr>
@@ -7217,8 +7178,8 @@
         </p:blipFill>
         <p:spPr>
           <a:xfrm>
-            <a:off x="320040" y="1417320"/>
-            <a:ext cx="11521440" cy="5006981"/>
+            <a:off x="256032" y="1024128"/>
+            <a:ext cx="11658600" cy="6088077"/>
           </a:xfrm>
           <a:prstGeom prst="rect">
             <a:avLst/>
@@ -7227,13 +7188,13 @@
       </p:pic>
       <p:sp>
         <p:nvSpPr>
-          <p:cNvPr id="9" name="TextBox 8"/>
-          <p:cNvSpPr txBox="1"/>
-          <p:nvPr/>
-        </p:nvSpPr>
-        <p:spPr>
-          <a:xfrm>
-            <a:off x="256032" y="6446520"/>
+          <p:cNvPr id="8" name="TextBox 7"/>
+          <p:cNvSpPr txBox="1"/>
+          <p:nvPr/>
+        </p:nvSpPr>
+        <p:spPr>
+          <a:xfrm>
+            <a:off x="256032" y="6473952"/>
             <a:ext cx="11612880" cy="201168"/>
           </a:xfrm>
           <a:prstGeom prst="rect">
@@ -7253,13 +7214,13 @@
               </a:spcAft>
             </a:pPr>
             <a:r>
-              <a:rPr sz="1400" b="1">
+              <a:rPr sz="1200" b="1">
                 <a:solidFill>
                   <a:srgbClr val="0D3B66"/>
                 </a:solidFill>
                 <a:latin typeface="Calibri"/>
               </a:rPr>
-              <a:t>Suma de las 5: 2.140 m³/mes  ·  $2.996.490</a:t>
+              <a:t>Ya operativo 999 m³/mes  ·  si se aprueban las 5: 3.139 m³/mes  ·  $4.395.090  ·  Sur no entra</a:t>
             </a:r>
           </a:p>
         </p:txBody>

</xml_diff>